<commit_message>
Add presentation update artifacts
</commit_message>
<xml_diff>
--- a/.codex-finalizer/cedims-system-candidate.pptx
+++ b/.codex-finalizer/cedims-system-candidate.pptx
@@ -2,22 +2,22 @@
 <file path=ppt/presentation.xml><?xml version="1.0" encoding="utf-8"?>
 <p:presentation xmlns:p="http://schemas.openxmlformats.org/presentationml/2006/main">
   <p:sldMasterIdLst>
-    <p:sldMasterId xmlns:r="http://schemas.openxmlformats.org/officeDocument/2006/relationships" id="2147483648" r:id="Rc2806613fd2e49aa"/>
+    <p:sldMasterId xmlns:r="http://schemas.openxmlformats.org/officeDocument/2006/relationships" id="2147483648" r:id="R97d095d737e24ed7"/>
   </p:sldMasterIdLst>
   <p:notesMasterIdLst>
-    <p:notesMasterId xmlns:r="http://schemas.openxmlformats.org/officeDocument/2006/relationships" r:id="R2e1b064b69094e96"/>
+    <p:notesMasterId xmlns:r="http://schemas.openxmlformats.org/officeDocument/2006/relationships" r:id="R03e930ad9fe349dc"/>
   </p:notesMasterIdLst>
   <p:sldIdLst>
-    <p:sldId xmlns:r="http://schemas.openxmlformats.org/officeDocument/2006/relationships" id="256" r:id="R1c99a9c3961e44e4"/>
-    <p:sldId xmlns:r="http://schemas.openxmlformats.org/officeDocument/2006/relationships" id="257" r:id="R6bfd883a9b7f4417"/>
-    <p:sldId xmlns:r="http://schemas.openxmlformats.org/officeDocument/2006/relationships" id="258" r:id="Rd17781241ab94879"/>
-    <p:sldId xmlns:r="http://schemas.openxmlformats.org/officeDocument/2006/relationships" id="259" r:id="R47f6c444fabd47c6"/>
-    <p:sldId xmlns:r="http://schemas.openxmlformats.org/officeDocument/2006/relationships" id="260" r:id="R57c67e1bd92740cd"/>
-    <p:sldId xmlns:r="http://schemas.openxmlformats.org/officeDocument/2006/relationships" id="261" r:id="Rd4bc68efd36f4854"/>
-    <p:sldId xmlns:r="http://schemas.openxmlformats.org/officeDocument/2006/relationships" id="262" r:id="Rad561112d4204e30"/>
-    <p:sldId xmlns:r="http://schemas.openxmlformats.org/officeDocument/2006/relationships" id="263" r:id="R9515d41f3d7d46b7"/>
-    <p:sldId xmlns:r="http://schemas.openxmlformats.org/officeDocument/2006/relationships" id="264" r:id="R2fac78f23e7e4f3a"/>
-    <p:sldId xmlns:r="http://schemas.openxmlformats.org/officeDocument/2006/relationships" id="265" r:id="R1fe52d04d02f4005"/>
+    <p:sldId xmlns:r="http://schemas.openxmlformats.org/officeDocument/2006/relationships" id="256" r:id="Rdf51cd72ee714b54"/>
+    <p:sldId xmlns:r="http://schemas.openxmlformats.org/officeDocument/2006/relationships" id="257" r:id="R0b846545f19b4281"/>
+    <p:sldId xmlns:r="http://schemas.openxmlformats.org/officeDocument/2006/relationships" id="258" r:id="R71ba835a6160478d"/>
+    <p:sldId xmlns:r="http://schemas.openxmlformats.org/officeDocument/2006/relationships" id="259" r:id="R639b2a5feed643f6"/>
+    <p:sldId xmlns:r="http://schemas.openxmlformats.org/officeDocument/2006/relationships" id="260" r:id="R00ba4522627b4b68"/>
+    <p:sldId xmlns:r="http://schemas.openxmlformats.org/officeDocument/2006/relationships" id="261" r:id="R47d255fd8df048fc"/>
+    <p:sldId xmlns:r="http://schemas.openxmlformats.org/officeDocument/2006/relationships" id="262" r:id="R7ed26b146cdb4c15"/>
+    <p:sldId xmlns:r="http://schemas.openxmlformats.org/officeDocument/2006/relationships" id="263" r:id="R5218dc06afeb4c4b"/>
+    <p:sldId xmlns:r="http://schemas.openxmlformats.org/officeDocument/2006/relationships" id="264" r:id="R24c256be084f472d"/>
+    <p:sldId xmlns:r="http://schemas.openxmlformats.org/officeDocument/2006/relationships" id="265" r:id="R748d9e8632614ebb"/>
   </p:sldIdLst>
   <p:sldSz cx="12192000" cy="6858000"/>
   <p:notesSz cx="6858000" cy="9144000"/>
@@ -1249,7 +1249,7 @@
   </p:cSld>
   <p:clrMap bg1="lt1" tx1="dk1" bg2="lt2" tx2="dk2" accent1="accent1" accent2="accent2" accent3="accent3" accent4="accent4" accent5="accent5" accent6="accent6" hlink="hlink" folHlink="folHlink"/>
   <p:sldLayoutIdLst>
-    <p:sldLayoutId xmlns:r="http://schemas.openxmlformats.org/officeDocument/2006/relationships" id="2147483649" r:id="Rcc714ac4d6d44952"/>
+    <p:sldLayoutId xmlns:r="http://schemas.openxmlformats.org/officeDocument/2006/relationships" id="2147483649" r:id="R5ad37703bf334c64"/>
   </p:sldLayoutIdLst>
   <p:txStyles>
     <p:titleStyle>
@@ -1804,7 +1804,7 @@
           <p:nvPr/>
         </p:nvPicPr>
         <p:blipFill>
-          <a:blip xmlns:r="http://schemas.openxmlformats.org/officeDocument/2006/relationships" xmlns:a="http://schemas.openxmlformats.org/drawingml/2006/main" r:embed="R0568996a83a24f1b"/>
+          <a:blip xmlns:r="http://schemas.openxmlformats.org/officeDocument/2006/relationships" xmlns:a="http://schemas.openxmlformats.org/drawingml/2006/main" r:embed="R26dba82e52404936"/>
           <a:srcRect xmlns:a="http://schemas.openxmlformats.org/drawingml/2006/main" l="7778" t="0" r="7778" b="0"/>
           <a:stretch xmlns:a="http://schemas.openxmlformats.org/drawingml/2006/main">
             <a:fillRect l="0" t="0" r="0" b="0"/>
@@ -1825,7 +1825,7 @@
           <p:cNvPr id="2" name="">
             <a:extLst xmlns:a="http://schemas.openxmlformats.org/drawingml/2006/main">
               <a:ext uri="{FF2B5EF4-FFF2-40B4-BE49-F238E27FC236}">
-                <a16:creationId xmlns:a16="http://schemas.microsoft.com/office/drawing/2014/main" id="{52CE35BC-1B98-40B9-AE6C-5A4CE39961D6}"/>
+                <a16:creationId xmlns:a16="http://schemas.microsoft.com/office/drawing/2014/main" id="{FDD42E1D-5226-4744-9993-742E23BBB639}"/>
               </a:ext>
             </a:extLst>
           </p:cNvPr>
@@ -1861,7 +1861,7 @@
           <p:nvPr/>
         </p:nvPicPr>
         <p:blipFill>
-          <a:blip xmlns:r="http://schemas.openxmlformats.org/officeDocument/2006/relationships" xmlns:a="http://schemas.openxmlformats.org/drawingml/2006/main" r:embed="Re1b44003d1b44445"/>
+          <a:blip xmlns:r="http://schemas.openxmlformats.org/officeDocument/2006/relationships" xmlns:a="http://schemas.openxmlformats.org/drawingml/2006/main" r:embed="R7519a64d1cd14e23"/>
           <a:stretch xmlns:a="http://schemas.openxmlformats.org/drawingml/2006/main"/>
         </p:blipFill>
         <p:spPr>
@@ -1883,7 +1883,7 @@
           <p:nvPr/>
         </p:nvPicPr>
         <p:blipFill>
-          <a:blip xmlns:r="http://schemas.openxmlformats.org/officeDocument/2006/relationships" xmlns:a="http://schemas.openxmlformats.org/drawingml/2006/main" r:embed="Rd335c849223a48e8"/>
+          <a:blip xmlns:r="http://schemas.openxmlformats.org/officeDocument/2006/relationships" xmlns:a="http://schemas.openxmlformats.org/drawingml/2006/main" r:embed="R25216a85b1894d31"/>
           <a:stretch xmlns:a="http://schemas.openxmlformats.org/drawingml/2006/main"/>
         </p:blipFill>
         <p:spPr>
@@ -1901,7 +1901,7 @@
           <p:cNvPr id="5" name="">
             <a:extLst xmlns:a="http://schemas.openxmlformats.org/drawingml/2006/main">
               <a:ext uri="{FF2B5EF4-FFF2-40B4-BE49-F238E27FC236}">
-                <a16:creationId xmlns:a16="http://schemas.microsoft.com/office/drawing/2014/main" id="{FAB132E5-5DDE-4A25-82FB-D2B678B4655B}"/>
+                <a16:creationId xmlns:a16="http://schemas.microsoft.com/office/drawing/2014/main" id="{E71A66E5-3A14-4F55-A858-69C4D38327A7}"/>
               </a:ext>
             </a:extLst>
           </p:cNvPr>
@@ -1958,7 +1958,7 @@
           <p:cNvPr id="6" name="">
             <a:extLst xmlns:a="http://schemas.openxmlformats.org/drawingml/2006/main">
               <a:ext uri="{FF2B5EF4-FFF2-40B4-BE49-F238E27FC236}">
-                <a16:creationId xmlns:a16="http://schemas.microsoft.com/office/drawing/2014/main" id="{BC79B93F-4136-4287-A6F7-18F54FDC6317}"/>
+                <a16:creationId xmlns:a16="http://schemas.microsoft.com/office/drawing/2014/main" id="{61920F8E-4DFD-4E6D-AB15-0C05D890D512}"/>
               </a:ext>
             </a:extLst>
           </p:cNvPr>
@@ -2038,7 +2038,7 @@
           <p:cNvPr id="7" name="">
             <a:extLst xmlns:a="http://schemas.openxmlformats.org/drawingml/2006/main">
               <a:ext uri="{FF2B5EF4-FFF2-40B4-BE49-F238E27FC236}">
-                <a16:creationId xmlns:a16="http://schemas.microsoft.com/office/drawing/2014/main" id="{B9EB2E92-2EBA-4CC8-9FC2-F66C14078900}"/>
+                <a16:creationId xmlns:a16="http://schemas.microsoft.com/office/drawing/2014/main" id="{4295A0EC-1137-4DD7-A846-E472261713E2}"/>
               </a:ext>
             </a:extLst>
           </p:cNvPr>
@@ -2095,7 +2095,7 @@
           <p:cNvPr id="8" name="">
             <a:extLst xmlns:a="http://schemas.openxmlformats.org/drawingml/2006/main">
               <a:ext uri="{FF2B5EF4-FFF2-40B4-BE49-F238E27FC236}">
-                <a16:creationId xmlns:a16="http://schemas.microsoft.com/office/drawing/2014/main" id="{5B73EC62-AA95-4DC4-B001-658DDB17AB2A}"/>
+                <a16:creationId xmlns:a16="http://schemas.microsoft.com/office/drawing/2014/main" id="{80B636DD-8B3D-4F5C-9585-88E731265D95}"/>
               </a:ext>
             </a:extLst>
           </p:cNvPr>
@@ -2150,7 +2150,7 @@
     </p:spTree>
     <p:extLst>
       <p:ext uri="{BB962C8B-B14F-4D97-AF65-F5344CB8AC3E}">
-        <p14:creationId xmlns:p14="http://schemas.microsoft.com/office/powerpoint/2010/main" val="860118811"/>
+        <p14:creationId xmlns:p14="http://schemas.microsoft.com/office/powerpoint/2010/main" val="95962269"/>
       </p:ext>
     </p:extLst>
   </p:cSld>
@@ -2185,7 +2185,7 @@
           <p:nvPr/>
         </p:nvPicPr>
         <p:blipFill>
-          <a:blip xmlns:r="http://schemas.openxmlformats.org/officeDocument/2006/relationships" xmlns:a="http://schemas.openxmlformats.org/drawingml/2006/main" r:embed="R25268e7d44ec4a5a"/>
+          <a:blip xmlns:r="http://schemas.openxmlformats.org/officeDocument/2006/relationships" xmlns:a="http://schemas.openxmlformats.org/drawingml/2006/main" r:embed="R9575fc63b5b5449a"/>
           <a:stretch xmlns:a="http://schemas.openxmlformats.org/drawingml/2006/main"/>
         </p:blipFill>
         <p:spPr>
@@ -2203,7 +2203,7 @@
           <p:cNvPr id="2" name="">
             <a:extLst xmlns:a="http://schemas.openxmlformats.org/drawingml/2006/main">
               <a:ext uri="{FF2B5EF4-FFF2-40B4-BE49-F238E27FC236}">
-                <a16:creationId xmlns:a16="http://schemas.microsoft.com/office/drawing/2014/main" id="{5F15CF57-F911-469A-B8AD-6412E504C240}"/>
+                <a16:creationId xmlns:a16="http://schemas.microsoft.com/office/drawing/2014/main" id="{9ACE3260-CE06-4390-B591-A175D5CC97EE}"/>
               </a:ext>
             </a:extLst>
           </p:cNvPr>
@@ -2260,7 +2260,7 @@
           <p:cNvPr id="3" name="">
             <a:extLst xmlns:a="http://schemas.openxmlformats.org/drawingml/2006/main">
               <a:ext uri="{FF2B5EF4-FFF2-40B4-BE49-F238E27FC236}">
-                <a16:creationId xmlns:a16="http://schemas.microsoft.com/office/drawing/2014/main" id="{5A593782-2B43-43C6-AD1B-C272046513E3}"/>
+                <a16:creationId xmlns:a16="http://schemas.microsoft.com/office/drawing/2014/main" id="{CBD7130D-9231-42C2-85C4-FAF778F0DB40}"/>
               </a:ext>
             </a:extLst>
           </p:cNvPr>
@@ -2317,7 +2317,7 @@
           <p:cNvPr id="4" name="">
             <a:extLst xmlns:a="http://schemas.openxmlformats.org/drawingml/2006/main">
               <a:ext uri="{FF2B5EF4-FFF2-40B4-BE49-F238E27FC236}">
-                <a16:creationId xmlns:a16="http://schemas.microsoft.com/office/drawing/2014/main" id="{85D219F6-F074-4AC0-8C51-223000253373}"/>
+                <a16:creationId xmlns:a16="http://schemas.microsoft.com/office/drawing/2014/main" id="{0F400183-6CA0-4CDA-BBFA-21463B9D8249}"/>
               </a:ext>
             </a:extLst>
           </p:cNvPr>
@@ -2352,7 +2352,7 @@
           <p:cNvPr id="5" name="">
             <a:extLst xmlns:a="http://schemas.openxmlformats.org/drawingml/2006/main">
               <a:ext uri="{FF2B5EF4-FFF2-40B4-BE49-F238E27FC236}">
-                <a16:creationId xmlns:a16="http://schemas.microsoft.com/office/drawing/2014/main" id="{4BDE2499-4BE3-41BC-AE39-C35FE3A33AD1}"/>
+                <a16:creationId xmlns:a16="http://schemas.microsoft.com/office/drawing/2014/main" id="{DDB6A87D-91C4-4CB2-8702-1049B4B41514}"/>
               </a:ext>
             </a:extLst>
           </p:cNvPr>
@@ -2409,7 +2409,7 @@
           <p:cNvPr id="6" name="">
             <a:extLst xmlns:a="http://schemas.openxmlformats.org/drawingml/2006/main">
               <a:ext uri="{FF2B5EF4-FFF2-40B4-BE49-F238E27FC236}">
-                <a16:creationId xmlns:a16="http://schemas.microsoft.com/office/drawing/2014/main" id="{082DBC54-B3A2-4A49-A9A1-E7C4335AF78D}"/>
+                <a16:creationId xmlns:a16="http://schemas.microsoft.com/office/drawing/2014/main" id="{6A4D8FA5-55BB-4737-87D1-1842C3CCE80E}"/>
               </a:ext>
             </a:extLst>
           </p:cNvPr>
@@ -2466,7 +2466,7 @@
           <p:cNvPr id="7" name="">
             <a:extLst xmlns:a="http://schemas.openxmlformats.org/drawingml/2006/main">
               <a:ext uri="{FF2B5EF4-FFF2-40B4-BE49-F238E27FC236}">
-                <a16:creationId xmlns:a16="http://schemas.microsoft.com/office/drawing/2014/main" id="{65B14323-5C32-4228-A455-C291A0696B77}"/>
+                <a16:creationId xmlns:a16="http://schemas.microsoft.com/office/drawing/2014/main" id="{9B2DBC1A-B86E-43DA-A2F9-B7018790FE4E}"/>
               </a:ext>
             </a:extLst>
           </p:cNvPr>
@@ -2523,7 +2523,7 @@
           <p:cNvPr id="8" name="">
             <a:extLst xmlns:a="http://schemas.openxmlformats.org/drawingml/2006/main">
               <a:ext uri="{FF2B5EF4-FFF2-40B4-BE49-F238E27FC236}">
-                <a16:creationId xmlns:a16="http://schemas.microsoft.com/office/drawing/2014/main" id="{0BCF9949-BED8-4869-8902-BDD146E065A1}"/>
+                <a16:creationId xmlns:a16="http://schemas.microsoft.com/office/drawing/2014/main" id="{25641B77-93D0-4BF2-869C-57BAAEA1B619}"/>
               </a:ext>
             </a:extLst>
           </p:cNvPr>
@@ -2578,7 +2578,7 @@
     </p:spTree>
     <p:extLst>
       <p:ext uri="{BB962C8B-B14F-4D97-AF65-F5344CB8AC3E}">
-        <p14:creationId xmlns:p14="http://schemas.microsoft.com/office/powerpoint/2010/main" val="224803554"/>
+        <p14:creationId xmlns:p14="http://schemas.microsoft.com/office/powerpoint/2010/main" val="573857537"/>
       </p:ext>
     </p:extLst>
   </p:cSld>
@@ -2609,7 +2609,7 @@
           <p:cNvPr id="19" name="">
             <a:extLst xmlns:a="http://schemas.openxmlformats.org/drawingml/2006/main">
               <a:ext uri="{FF2B5EF4-FFF2-40B4-BE49-F238E27FC236}">
-                <a16:creationId xmlns:a16="http://schemas.microsoft.com/office/drawing/2014/main" id="{2A7C0EF2-BE09-4CF4-97D5-1DA247E1658A}"/>
+                <a16:creationId xmlns:a16="http://schemas.microsoft.com/office/drawing/2014/main" id="{76F20768-2C95-415D-9DC6-4CC1A2D810D9}"/>
               </a:ext>
             </a:extLst>
           </p:cNvPr>
@@ -2666,7 +2666,7 @@
           <p:cNvPr id="2" name="">
             <a:extLst xmlns:a="http://schemas.openxmlformats.org/drawingml/2006/main">
               <a:ext uri="{FF2B5EF4-FFF2-40B4-BE49-F238E27FC236}">
-                <a16:creationId xmlns:a16="http://schemas.microsoft.com/office/drawing/2014/main" id="{1A90081A-BF61-41C9-A4EC-5EB972FBDAE1}"/>
+                <a16:creationId xmlns:a16="http://schemas.microsoft.com/office/drawing/2014/main" id="{753875E7-28D9-4E56-8BAD-FDED1F7B1577}"/>
               </a:ext>
             </a:extLst>
           </p:cNvPr>
@@ -2727,7 +2727,7 @@
           <p:nvPr/>
         </p:nvPicPr>
         <p:blipFill>
-          <a:blip xmlns:r="http://schemas.openxmlformats.org/officeDocument/2006/relationships" xmlns:a="http://schemas.openxmlformats.org/drawingml/2006/main" r:embed="R0e85822cb91a42c2"/>
+          <a:blip xmlns:r="http://schemas.openxmlformats.org/officeDocument/2006/relationships" xmlns:a="http://schemas.openxmlformats.org/drawingml/2006/main" r:embed="R276a4d5e69204f73"/>
           <a:stretch xmlns:a="http://schemas.openxmlformats.org/drawingml/2006/main"/>
         </p:blipFill>
         <p:spPr>
@@ -2745,7 +2745,7 @@
           <p:cNvPr id="4" name="">
             <a:extLst xmlns:a="http://schemas.openxmlformats.org/drawingml/2006/main">
               <a:ext uri="{FF2B5EF4-FFF2-40B4-BE49-F238E27FC236}">
-                <a16:creationId xmlns:a16="http://schemas.microsoft.com/office/drawing/2014/main" id="{1FAF42A4-2EB5-43B3-A16F-4EA22F145916}"/>
+                <a16:creationId xmlns:a16="http://schemas.microsoft.com/office/drawing/2014/main" id="{9F0F79FF-A114-4AA4-BB15-66B7C547442F}"/>
               </a:ext>
             </a:extLst>
           </p:cNvPr>
@@ -2802,7 +2802,7 @@
           <p:cNvPr id="5" name="">
             <a:extLst xmlns:a="http://schemas.openxmlformats.org/drawingml/2006/main">
               <a:ext uri="{FF2B5EF4-FFF2-40B4-BE49-F238E27FC236}">
-                <a16:creationId xmlns:a16="http://schemas.microsoft.com/office/drawing/2014/main" id="{1B14BE63-5711-44ED-93AC-993BE306C02A}"/>
+                <a16:creationId xmlns:a16="http://schemas.microsoft.com/office/drawing/2014/main" id="{90CDF42E-EFA1-4FA9-B51E-2D3A91FB4958}"/>
               </a:ext>
             </a:extLst>
           </p:cNvPr>
@@ -2837,7 +2837,7 @@
           <p:cNvPr id="6" name="">
             <a:extLst xmlns:a="http://schemas.openxmlformats.org/drawingml/2006/main">
               <a:ext uri="{FF2B5EF4-FFF2-40B4-BE49-F238E27FC236}">
-                <a16:creationId xmlns:a16="http://schemas.microsoft.com/office/drawing/2014/main" id="{0E496D38-0A6A-4004-B0A8-94C9D2F9E94E}"/>
+                <a16:creationId xmlns:a16="http://schemas.microsoft.com/office/drawing/2014/main" id="{6448DC60-2BAD-47FA-A9E5-03827CB880E2}"/>
               </a:ext>
             </a:extLst>
           </p:cNvPr>
@@ -2867,7 +2867,7 @@
           <p:cNvPr id="7" name="">
             <a:extLst xmlns:a="http://schemas.openxmlformats.org/drawingml/2006/main">
               <a:ext uri="{FF2B5EF4-FFF2-40B4-BE49-F238E27FC236}">
-                <a16:creationId xmlns:a16="http://schemas.microsoft.com/office/drawing/2014/main" id="{5BD15C7F-4C61-4A3E-9E09-10A42D9CF8F2}"/>
+                <a16:creationId xmlns:a16="http://schemas.microsoft.com/office/drawing/2014/main" id="{0045A420-6F3D-4064-88AA-097C42C69E9B}"/>
               </a:ext>
             </a:extLst>
           </p:cNvPr>
@@ -2924,7 +2924,7 @@
           <p:cNvPr id="8" name="">
             <a:extLst xmlns:a="http://schemas.openxmlformats.org/drawingml/2006/main">
               <a:ext uri="{FF2B5EF4-FFF2-40B4-BE49-F238E27FC236}">
-                <a16:creationId xmlns:a16="http://schemas.microsoft.com/office/drawing/2014/main" id="{7453C530-C416-428B-88E9-E09289F2B631}"/>
+                <a16:creationId xmlns:a16="http://schemas.microsoft.com/office/drawing/2014/main" id="{AAF2EF65-2272-44A4-8A30-6CBB1F486CCD}"/>
               </a:ext>
             </a:extLst>
           </p:cNvPr>
@@ -2959,7 +2959,7 @@
           <p:cNvPr id="9" name="">
             <a:extLst xmlns:a="http://schemas.openxmlformats.org/drawingml/2006/main">
               <a:ext uri="{FF2B5EF4-FFF2-40B4-BE49-F238E27FC236}">
-                <a16:creationId xmlns:a16="http://schemas.microsoft.com/office/drawing/2014/main" id="{69787C7F-2A3A-4F80-B740-491822B20CDB}"/>
+                <a16:creationId xmlns:a16="http://schemas.microsoft.com/office/drawing/2014/main" id="{459F1DE9-D340-443A-8A6D-67EDD118042A}"/>
               </a:ext>
             </a:extLst>
           </p:cNvPr>
@@ -2989,7 +2989,7 @@
           <p:cNvPr id="10" name="">
             <a:extLst xmlns:a="http://schemas.openxmlformats.org/drawingml/2006/main">
               <a:ext uri="{FF2B5EF4-FFF2-40B4-BE49-F238E27FC236}">
-                <a16:creationId xmlns:a16="http://schemas.microsoft.com/office/drawing/2014/main" id="{889D8352-68E4-40B9-8A97-3202613EA631}"/>
+                <a16:creationId xmlns:a16="http://schemas.microsoft.com/office/drawing/2014/main" id="{468E7CF9-ADCE-4157-B896-5840DC8B3C08}"/>
               </a:ext>
             </a:extLst>
           </p:cNvPr>
@@ -3046,7 +3046,7 @@
           <p:cNvPr id="11" name="">
             <a:extLst xmlns:a="http://schemas.openxmlformats.org/drawingml/2006/main">
               <a:ext uri="{FF2B5EF4-FFF2-40B4-BE49-F238E27FC236}">
-                <a16:creationId xmlns:a16="http://schemas.microsoft.com/office/drawing/2014/main" id="{5D3A712C-C411-46F7-B334-2F1A1534DEA8}"/>
+                <a16:creationId xmlns:a16="http://schemas.microsoft.com/office/drawing/2014/main" id="{582BB75D-6391-48B4-911B-A2B35D567CB9}"/>
               </a:ext>
             </a:extLst>
           </p:cNvPr>
@@ -3081,7 +3081,7 @@
           <p:cNvPr id="12" name="">
             <a:extLst xmlns:a="http://schemas.openxmlformats.org/drawingml/2006/main">
               <a:ext uri="{FF2B5EF4-FFF2-40B4-BE49-F238E27FC236}">
-                <a16:creationId xmlns:a16="http://schemas.microsoft.com/office/drawing/2014/main" id="{1F6097AF-AFB9-4AB9-BAE8-A0EA1627478C}"/>
+                <a16:creationId xmlns:a16="http://schemas.microsoft.com/office/drawing/2014/main" id="{B95DFE9C-F16A-466C-A181-00FC17F98800}"/>
               </a:ext>
             </a:extLst>
           </p:cNvPr>
@@ -3111,7 +3111,7 @@
           <p:cNvPr id="13" name="">
             <a:extLst xmlns:a="http://schemas.openxmlformats.org/drawingml/2006/main">
               <a:ext uri="{FF2B5EF4-FFF2-40B4-BE49-F238E27FC236}">
-                <a16:creationId xmlns:a16="http://schemas.microsoft.com/office/drawing/2014/main" id="{372B120E-F11A-4324-9361-7B9AB81FDB25}"/>
+                <a16:creationId xmlns:a16="http://schemas.microsoft.com/office/drawing/2014/main" id="{5273A986-35D9-4E19-80C7-CD54C93FCC3B}"/>
               </a:ext>
             </a:extLst>
           </p:cNvPr>
@@ -3168,7 +3168,7 @@
           <p:cNvPr id="14" name="">
             <a:extLst xmlns:a="http://schemas.openxmlformats.org/drawingml/2006/main">
               <a:ext uri="{FF2B5EF4-FFF2-40B4-BE49-F238E27FC236}">
-                <a16:creationId xmlns:a16="http://schemas.microsoft.com/office/drawing/2014/main" id="{9905CE79-76B0-4C7B-A436-A2CD4A7AF440}"/>
+                <a16:creationId xmlns:a16="http://schemas.microsoft.com/office/drawing/2014/main" id="{9056ADDB-B231-4B8C-B679-5162B614B502}"/>
               </a:ext>
             </a:extLst>
           </p:cNvPr>
@@ -3203,7 +3203,7 @@
           <p:cNvPr id="15" name="">
             <a:extLst xmlns:a="http://schemas.openxmlformats.org/drawingml/2006/main">
               <a:ext uri="{FF2B5EF4-FFF2-40B4-BE49-F238E27FC236}">
-                <a16:creationId xmlns:a16="http://schemas.microsoft.com/office/drawing/2014/main" id="{BF9BBB63-A70B-4AC8-8E4C-16D7CEB60D76}"/>
+                <a16:creationId xmlns:a16="http://schemas.microsoft.com/office/drawing/2014/main" id="{EA6377EE-4F53-4F8E-ACD9-1153DBEE9C05}"/>
               </a:ext>
             </a:extLst>
           </p:cNvPr>
@@ -3233,7 +3233,7 @@
           <p:cNvPr id="16" name="">
             <a:extLst xmlns:a="http://schemas.openxmlformats.org/drawingml/2006/main">
               <a:ext uri="{FF2B5EF4-FFF2-40B4-BE49-F238E27FC236}">
-                <a16:creationId xmlns:a16="http://schemas.microsoft.com/office/drawing/2014/main" id="{AB67FBC9-74B4-45CA-94E3-51B90C03847A}"/>
+                <a16:creationId xmlns:a16="http://schemas.microsoft.com/office/drawing/2014/main" id="{D28E29A6-6C21-4F15-9403-57BA84D85B41}"/>
               </a:ext>
             </a:extLst>
           </p:cNvPr>
@@ -3290,7 +3290,7 @@
           <p:cNvPr id="17" name="">
             <a:extLst xmlns:a="http://schemas.openxmlformats.org/drawingml/2006/main">
               <a:ext uri="{FF2B5EF4-FFF2-40B4-BE49-F238E27FC236}">
-                <a16:creationId xmlns:a16="http://schemas.microsoft.com/office/drawing/2014/main" id="{0E7BEF09-07FB-46A5-8D39-03DAAF1584D0}"/>
+                <a16:creationId xmlns:a16="http://schemas.microsoft.com/office/drawing/2014/main" id="{8C127449-CAD7-48A5-B86F-DF29362A6329}"/>
               </a:ext>
             </a:extLst>
           </p:cNvPr>
@@ -3347,7 +3347,7 @@
           <p:cNvPr id="18" name="">
             <a:extLst xmlns:a="http://schemas.openxmlformats.org/drawingml/2006/main">
               <a:ext uri="{FF2B5EF4-FFF2-40B4-BE49-F238E27FC236}">
-                <a16:creationId xmlns:a16="http://schemas.microsoft.com/office/drawing/2014/main" id="{C1001872-6791-442E-BECC-3046EE5B54DD}"/>
+                <a16:creationId xmlns:a16="http://schemas.microsoft.com/office/drawing/2014/main" id="{08DBE48A-411B-4D97-A553-A3E3753403DA}"/>
               </a:ext>
             </a:extLst>
           </p:cNvPr>
@@ -3402,7 +3402,7 @@
     </p:spTree>
     <p:extLst>
       <p:ext uri="{BB962C8B-B14F-4D97-AF65-F5344CB8AC3E}">
-        <p14:creationId xmlns:p14="http://schemas.microsoft.com/office/powerpoint/2010/main" val="1594237514"/>
+        <p14:creationId xmlns:p14="http://schemas.microsoft.com/office/powerpoint/2010/main" val="1566387209"/>
       </p:ext>
     </p:extLst>
   </p:cSld>
@@ -3433,7 +3433,7 @@
           <p:cNvPr id="32" name="">
             <a:extLst xmlns:a="http://schemas.openxmlformats.org/drawingml/2006/main">
               <a:ext uri="{FF2B5EF4-FFF2-40B4-BE49-F238E27FC236}">
-                <a16:creationId xmlns:a16="http://schemas.microsoft.com/office/drawing/2014/main" id="{29CCB7CB-8153-48D4-A98C-5F855EBFE601}"/>
+                <a16:creationId xmlns:a16="http://schemas.microsoft.com/office/drawing/2014/main" id="{BF3985B1-16FC-418D-A9B4-948912D07062}"/>
               </a:ext>
             </a:extLst>
           </p:cNvPr>
@@ -3490,7 +3490,7 @@
           <p:cNvPr id="2" name="">
             <a:extLst xmlns:a="http://schemas.openxmlformats.org/drawingml/2006/main">
               <a:ext uri="{FF2B5EF4-FFF2-40B4-BE49-F238E27FC236}">
-                <a16:creationId xmlns:a16="http://schemas.microsoft.com/office/drawing/2014/main" id="{B2F55ADE-B177-4433-BAEB-89D8E658E45E}"/>
+                <a16:creationId xmlns:a16="http://schemas.microsoft.com/office/drawing/2014/main" id="{FD340291-24B6-4D5E-B854-98810CE6E717}"/>
               </a:ext>
             </a:extLst>
           </p:cNvPr>
@@ -3551,7 +3551,7 @@
           <p:nvPr/>
         </p:nvPicPr>
         <p:blipFill>
-          <a:blip xmlns:r="http://schemas.openxmlformats.org/officeDocument/2006/relationships" xmlns:a="http://schemas.openxmlformats.org/drawingml/2006/main" r:embed="R50ed5dcf4811499e"/>
+          <a:blip xmlns:r="http://schemas.openxmlformats.org/officeDocument/2006/relationships" xmlns:a="http://schemas.openxmlformats.org/drawingml/2006/main" r:embed="Rbce1f5f6a2c145e5"/>
           <a:stretch xmlns:a="http://schemas.openxmlformats.org/drawingml/2006/main"/>
         </p:blipFill>
         <p:spPr>
@@ -3569,7 +3569,7 @@
           <p:cNvPr id="4" name="">
             <a:extLst xmlns:a="http://schemas.openxmlformats.org/drawingml/2006/main">
               <a:ext uri="{FF2B5EF4-FFF2-40B4-BE49-F238E27FC236}">
-                <a16:creationId xmlns:a16="http://schemas.microsoft.com/office/drawing/2014/main" id="{A4B90557-8F09-4563-BEAF-9D91AF6A5F40}"/>
+                <a16:creationId xmlns:a16="http://schemas.microsoft.com/office/drawing/2014/main" id="{8463E424-B211-4334-B463-59BD0B614D0A}"/>
               </a:ext>
             </a:extLst>
           </p:cNvPr>
@@ -3604,7 +3604,7 @@
           <p:cNvPr id="5" name="">
             <a:extLst xmlns:a="http://schemas.openxmlformats.org/drawingml/2006/main">
               <a:ext uri="{FF2B5EF4-FFF2-40B4-BE49-F238E27FC236}">
-                <a16:creationId xmlns:a16="http://schemas.microsoft.com/office/drawing/2014/main" id="{F92DF41B-F2A5-4177-B94C-5599C8CD6A00}"/>
+                <a16:creationId xmlns:a16="http://schemas.microsoft.com/office/drawing/2014/main" id="{E31BFA93-8CF7-4633-991F-4DC35BA7FB9B}"/>
               </a:ext>
             </a:extLst>
           </p:cNvPr>
@@ -3634,7 +3634,7 @@
           <p:cNvPr id="6" name="">
             <a:extLst xmlns:a="http://schemas.openxmlformats.org/drawingml/2006/main">
               <a:ext uri="{FF2B5EF4-FFF2-40B4-BE49-F238E27FC236}">
-                <a16:creationId xmlns:a16="http://schemas.microsoft.com/office/drawing/2014/main" id="{5C0C940D-F96E-4147-92E9-6E18D526D08C}"/>
+                <a16:creationId xmlns:a16="http://schemas.microsoft.com/office/drawing/2014/main" id="{C8C700D8-BF72-4DC7-A341-BF83F2D45E39}"/>
               </a:ext>
             </a:extLst>
           </p:cNvPr>
@@ -3691,7 +3691,7 @@
           <p:cNvPr id="7" name="">
             <a:extLst xmlns:a="http://schemas.openxmlformats.org/drawingml/2006/main">
               <a:ext uri="{FF2B5EF4-FFF2-40B4-BE49-F238E27FC236}">
-                <a16:creationId xmlns:a16="http://schemas.microsoft.com/office/drawing/2014/main" id="{A0C8F636-C2E4-4297-9305-719E2C3D6471}"/>
+                <a16:creationId xmlns:a16="http://schemas.microsoft.com/office/drawing/2014/main" id="{4FBAB8AB-5E36-4271-ABAC-66683AC369A0}"/>
               </a:ext>
             </a:extLst>
           </p:cNvPr>
@@ -3748,7 +3748,7 @@
           <p:cNvPr id="8" name="">
             <a:extLst xmlns:a="http://schemas.openxmlformats.org/drawingml/2006/main">
               <a:ext uri="{FF2B5EF4-FFF2-40B4-BE49-F238E27FC236}">
-                <a16:creationId xmlns:a16="http://schemas.microsoft.com/office/drawing/2014/main" id="{68A6F6DB-BAA5-4F9F-81F9-D90FEF8448D6}"/>
+                <a16:creationId xmlns:a16="http://schemas.microsoft.com/office/drawing/2014/main" id="{C9F17995-403E-470B-B09A-135BBA788F03}"/>
               </a:ext>
             </a:extLst>
           </p:cNvPr>
@@ -3805,7 +3805,7 @@
           <p:cNvPr id="9" name="">
             <a:extLst xmlns:a="http://schemas.openxmlformats.org/drawingml/2006/main">
               <a:ext uri="{FF2B5EF4-FFF2-40B4-BE49-F238E27FC236}">
-                <a16:creationId xmlns:a16="http://schemas.microsoft.com/office/drawing/2014/main" id="{F957F706-7F6B-4F40-A153-148D93D833EA}"/>
+                <a16:creationId xmlns:a16="http://schemas.microsoft.com/office/drawing/2014/main" id="{BCF4C071-F198-4E03-887A-99903997C7E0}"/>
               </a:ext>
             </a:extLst>
           </p:cNvPr>
@@ -3840,7 +3840,7 @@
           <p:cNvPr id="10" name="">
             <a:extLst xmlns:a="http://schemas.openxmlformats.org/drawingml/2006/main">
               <a:ext uri="{FF2B5EF4-FFF2-40B4-BE49-F238E27FC236}">
-                <a16:creationId xmlns:a16="http://schemas.microsoft.com/office/drawing/2014/main" id="{EF3C6484-DEE5-4E06-A63C-1C1D666BDD3D}"/>
+                <a16:creationId xmlns:a16="http://schemas.microsoft.com/office/drawing/2014/main" id="{8B192DB2-8842-4396-870B-BE899DF38B9E}"/>
               </a:ext>
             </a:extLst>
           </p:cNvPr>
@@ -3870,7 +3870,7 @@
           <p:cNvPr id="11" name="">
             <a:extLst xmlns:a="http://schemas.openxmlformats.org/drawingml/2006/main">
               <a:ext uri="{FF2B5EF4-FFF2-40B4-BE49-F238E27FC236}">
-                <a16:creationId xmlns:a16="http://schemas.microsoft.com/office/drawing/2014/main" id="{5468FC6F-CD85-4837-A023-1F1C933E367B}"/>
+                <a16:creationId xmlns:a16="http://schemas.microsoft.com/office/drawing/2014/main" id="{4C77BB24-0F98-4E14-867A-1C6DDDAB5CE5}"/>
               </a:ext>
             </a:extLst>
           </p:cNvPr>
@@ -3927,7 +3927,7 @@
           <p:cNvPr id="12" name="">
             <a:extLst xmlns:a="http://schemas.openxmlformats.org/drawingml/2006/main">
               <a:ext uri="{FF2B5EF4-FFF2-40B4-BE49-F238E27FC236}">
-                <a16:creationId xmlns:a16="http://schemas.microsoft.com/office/drawing/2014/main" id="{66682FC6-0604-4AC6-A38C-70EA67A96B3A}"/>
+                <a16:creationId xmlns:a16="http://schemas.microsoft.com/office/drawing/2014/main" id="{44256DC1-FAED-46DA-B14A-650B8115E4D1}"/>
               </a:ext>
             </a:extLst>
           </p:cNvPr>
@@ -3984,7 +3984,7 @@
           <p:cNvPr id="13" name="">
             <a:extLst xmlns:a="http://schemas.openxmlformats.org/drawingml/2006/main">
               <a:ext uri="{FF2B5EF4-FFF2-40B4-BE49-F238E27FC236}">
-                <a16:creationId xmlns:a16="http://schemas.microsoft.com/office/drawing/2014/main" id="{DFED7EB2-BF02-4967-B68A-33993FDCF044}"/>
+                <a16:creationId xmlns:a16="http://schemas.microsoft.com/office/drawing/2014/main" id="{FBD871E9-247D-4F5A-8C26-56DC695B305B}"/>
               </a:ext>
             </a:extLst>
           </p:cNvPr>
@@ -4041,7 +4041,7 @@
           <p:cNvPr id="14" name="">
             <a:extLst xmlns:a="http://schemas.openxmlformats.org/drawingml/2006/main">
               <a:ext uri="{FF2B5EF4-FFF2-40B4-BE49-F238E27FC236}">
-                <a16:creationId xmlns:a16="http://schemas.microsoft.com/office/drawing/2014/main" id="{78A3BB3C-BCB4-4A72-ABD3-360848487B10}"/>
+                <a16:creationId xmlns:a16="http://schemas.microsoft.com/office/drawing/2014/main" id="{39730656-DF00-4C1F-BE66-C35CE712B96E}"/>
               </a:ext>
             </a:extLst>
           </p:cNvPr>
@@ -4076,7 +4076,7 @@
           <p:cNvPr id="15" name="">
             <a:extLst xmlns:a="http://schemas.openxmlformats.org/drawingml/2006/main">
               <a:ext uri="{FF2B5EF4-FFF2-40B4-BE49-F238E27FC236}">
-                <a16:creationId xmlns:a16="http://schemas.microsoft.com/office/drawing/2014/main" id="{23FF715F-2E55-4DD1-BC7E-032AE60A1F81}"/>
+                <a16:creationId xmlns:a16="http://schemas.microsoft.com/office/drawing/2014/main" id="{7B64EB7A-2C4D-4552-80B9-04F9B2898E93}"/>
               </a:ext>
             </a:extLst>
           </p:cNvPr>
@@ -4106,7 +4106,7 @@
           <p:cNvPr id="16" name="">
             <a:extLst xmlns:a="http://schemas.openxmlformats.org/drawingml/2006/main">
               <a:ext uri="{FF2B5EF4-FFF2-40B4-BE49-F238E27FC236}">
-                <a16:creationId xmlns:a16="http://schemas.microsoft.com/office/drawing/2014/main" id="{6AF5E673-E938-4249-871B-31DBD6B06C9D}"/>
+                <a16:creationId xmlns:a16="http://schemas.microsoft.com/office/drawing/2014/main" id="{B88A4F03-549F-4787-890E-7E95A724CFC7}"/>
               </a:ext>
             </a:extLst>
           </p:cNvPr>
@@ -4163,7 +4163,7 @@
           <p:cNvPr id="17" name="">
             <a:extLst xmlns:a="http://schemas.openxmlformats.org/drawingml/2006/main">
               <a:ext uri="{FF2B5EF4-FFF2-40B4-BE49-F238E27FC236}">
-                <a16:creationId xmlns:a16="http://schemas.microsoft.com/office/drawing/2014/main" id="{A40E41E0-53B7-41C5-AD99-48C3FE8C6A40}"/>
+                <a16:creationId xmlns:a16="http://schemas.microsoft.com/office/drawing/2014/main" id="{BB35BBF8-7201-43B7-BF8F-8B1627743506}"/>
               </a:ext>
             </a:extLst>
           </p:cNvPr>
@@ -4220,7 +4220,7 @@
           <p:cNvPr id="18" name="">
             <a:extLst xmlns:a="http://schemas.openxmlformats.org/drawingml/2006/main">
               <a:ext uri="{FF2B5EF4-FFF2-40B4-BE49-F238E27FC236}">
-                <a16:creationId xmlns:a16="http://schemas.microsoft.com/office/drawing/2014/main" id="{931ABBCE-2CE1-4818-9529-20F00CDAB303}"/>
+                <a16:creationId xmlns:a16="http://schemas.microsoft.com/office/drawing/2014/main" id="{FB276FEE-80E8-4F39-AB3A-AA889322A0E2}"/>
               </a:ext>
             </a:extLst>
           </p:cNvPr>
@@ -4277,7 +4277,7 @@
           <p:cNvPr id="19" name="">
             <a:extLst xmlns:a="http://schemas.openxmlformats.org/drawingml/2006/main">
               <a:ext uri="{FF2B5EF4-FFF2-40B4-BE49-F238E27FC236}">
-                <a16:creationId xmlns:a16="http://schemas.microsoft.com/office/drawing/2014/main" id="{A5272C63-9108-4AE8-87BB-DD651CC2D58A}"/>
+                <a16:creationId xmlns:a16="http://schemas.microsoft.com/office/drawing/2014/main" id="{B3CCDC6D-CE6F-4101-A8A9-7682C225E2C5}"/>
               </a:ext>
             </a:extLst>
           </p:cNvPr>
@@ -4312,7 +4312,7 @@
           <p:cNvPr id="20" name="">
             <a:extLst xmlns:a="http://schemas.openxmlformats.org/drawingml/2006/main">
               <a:ext uri="{FF2B5EF4-FFF2-40B4-BE49-F238E27FC236}">
-                <a16:creationId xmlns:a16="http://schemas.microsoft.com/office/drawing/2014/main" id="{506DCA1A-705D-4088-AC6A-20FA3325C989}"/>
+                <a16:creationId xmlns:a16="http://schemas.microsoft.com/office/drawing/2014/main" id="{0561F738-1021-4A03-991C-1BBF30E15595}"/>
               </a:ext>
             </a:extLst>
           </p:cNvPr>
@@ -4342,7 +4342,7 @@
           <p:cNvPr id="21" name="">
             <a:extLst xmlns:a="http://schemas.openxmlformats.org/drawingml/2006/main">
               <a:ext uri="{FF2B5EF4-FFF2-40B4-BE49-F238E27FC236}">
-                <a16:creationId xmlns:a16="http://schemas.microsoft.com/office/drawing/2014/main" id="{941447B3-5675-4704-9448-83B56A2C1097}"/>
+                <a16:creationId xmlns:a16="http://schemas.microsoft.com/office/drawing/2014/main" id="{F9CE6B0D-1B2E-4697-8CAA-0F2E3EF0A89A}"/>
               </a:ext>
             </a:extLst>
           </p:cNvPr>
@@ -4399,7 +4399,7 @@
           <p:cNvPr id="22" name="">
             <a:extLst xmlns:a="http://schemas.openxmlformats.org/drawingml/2006/main">
               <a:ext uri="{FF2B5EF4-FFF2-40B4-BE49-F238E27FC236}">
-                <a16:creationId xmlns:a16="http://schemas.microsoft.com/office/drawing/2014/main" id="{99D5F10A-4AF6-4E07-AC6E-B3FCC12FEADA}"/>
+                <a16:creationId xmlns:a16="http://schemas.microsoft.com/office/drawing/2014/main" id="{A41EA2BE-1F16-4A63-9D59-03DBCBEDC817}"/>
               </a:ext>
             </a:extLst>
           </p:cNvPr>
@@ -4456,7 +4456,7 @@
           <p:cNvPr id="23" name="">
             <a:extLst xmlns:a="http://schemas.openxmlformats.org/drawingml/2006/main">
               <a:ext uri="{FF2B5EF4-FFF2-40B4-BE49-F238E27FC236}">
-                <a16:creationId xmlns:a16="http://schemas.microsoft.com/office/drawing/2014/main" id="{48755DEA-0FCA-4625-81F7-E5E3FBD45402}"/>
+                <a16:creationId xmlns:a16="http://schemas.microsoft.com/office/drawing/2014/main" id="{45B19193-1783-4F0C-8259-84E48624349E}"/>
               </a:ext>
             </a:extLst>
           </p:cNvPr>
@@ -4513,7 +4513,7 @@
           <p:cNvPr id="24" name="">
             <a:extLst xmlns:a="http://schemas.openxmlformats.org/drawingml/2006/main">
               <a:ext uri="{FF2B5EF4-FFF2-40B4-BE49-F238E27FC236}">
-                <a16:creationId xmlns:a16="http://schemas.microsoft.com/office/drawing/2014/main" id="{D49B6D34-5A43-4391-AD57-7B08A2E9446E}"/>
+                <a16:creationId xmlns:a16="http://schemas.microsoft.com/office/drawing/2014/main" id="{972B841F-410A-43C2-91FA-F20E92EBA301}"/>
               </a:ext>
             </a:extLst>
           </p:cNvPr>
@@ -4548,7 +4548,7 @@
           <p:cNvPr id="25" name="">
             <a:extLst xmlns:a="http://schemas.openxmlformats.org/drawingml/2006/main">
               <a:ext uri="{FF2B5EF4-FFF2-40B4-BE49-F238E27FC236}">
-                <a16:creationId xmlns:a16="http://schemas.microsoft.com/office/drawing/2014/main" id="{90A1FF46-2AB1-4373-8DB9-B5A147D9D63C}"/>
+                <a16:creationId xmlns:a16="http://schemas.microsoft.com/office/drawing/2014/main" id="{74BF33F8-F738-4726-B281-130CDD499C9F}"/>
               </a:ext>
             </a:extLst>
           </p:cNvPr>
@@ -4578,7 +4578,7 @@
           <p:cNvPr id="26" name="">
             <a:extLst xmlns:a="http://schemas.openxmlformats.org/drawingml/2006/main">
               <a:ext uri="{FF2B5EF4-FFF2-40B4-BE49-F238E27FC236}">
-                <a16:creationId xmlns:a16="http://schemas.microsoft.com/office/drawing/2014/main" id="{9CC30216-500A-4266-9202-0D88E0D59888}"/>
+                <a16:creationId xmlns:a16="http://schemas.microsoft.com/office/drawing/2014/main" id="{AE0E5C7A-3A2E-4AA8-AE93-B3A3418294EF}"/>
               </a:ext>
             </a:extLst>
           </p:cNvPr>
@@ -4635,7 +4635,7 @@
           <p:cNvPr id="27" name="">
             <a:extLst xmlns:a="http://schemas.openxmlformats.org/drawingml/2006/main">
               <a:ext uri="{FF2B5EF4-FFF2-40B4-BE49-F238E27FC236}">
-                <a16:creationId xmlns:a16="http://schemas.microsoft.com/office/drawing/2014/main" id="{E7F14890-525E-4380-85D0-289A00F369DB}"/>
+                <a16:creationId xmlns:a16="http://schemas.microsoft.com/office/drawing/2014/main" id="{8E2305B8-7852-4272-BE07-A28BA3CE84B1}"/>
               </a:ext>
             </a:extLst>
           </p:cNvPr>
@@ -4692,7 +4692,7 @@
           <p:cNvPr id="28" name="">
             <a:extLst xmlns:a="http://schemas.openxmlformats.org/drawingml/2006/main">
               <a:ext uri="{FF2B5EF4-FFF2-40B4-BE49-F238E27FC236}">
-                <a16:creationId xmlns:a16="http://schemas.microsoft.com/office/drawing/2014/main" id="{C46A3D19-80A4-4B25-8FA8-3C59F948FB1E}"/>
+                <a16:creationId xmlns:a16="http://schemas.microsoft.com/office/drawing/2014/main" id="{66CFAB8A-9F0B-40F6-824A-C5EA07AC6684}"/>
               </a:ext>
             </a:extLst>
           </p:cNvPr>
@@ -4749,7 +4749,7 @@
           <p:cNvPr id="29" name="">
             <a:extLst xmlns:a="http://schemas.openxmlformats.org/drawingml/2006/main">
               <a:ext uri="{FF2B5EF4-FFF2-40B4-BE49-F238E27FC236}">
-                <a16:creationId xmlns:a16="http://schemas.microsoft.com/office/drawing/2014/main" id="{FDF8269D-2A8C-4F45-AC68-1BABAF8F580D}"/>
+                <a16:creationId xmlns:a16="http://schemas.microsoft.com/office/drawing/2014/main" id="{7CB84EF9-8F29-493B-9829-15A142692E2A}"/>
               </a:ext>
             </a:extLst>
           </p:cNvPr>
@@ -4806,7 +4806,7 @@
           <p:cNvPr id="30" name="">
             <a:extLst xmlns:a="http://schemas.openxmlformats.org/drawingml/2006/main">
               <a:ext uri="{FF2B5EF4-FFF2-40B4-BE49-F238E27FC236}">
-                <a16:creationId xmlns:a16="http://schemas.microsoft.com/office/drawing/2014/main" id="{2C0BBC65-FC93-4094-9032-618677A87423}"/>
+                <a16:creationId xmlns:a16="http://schemas.microsoft.com/office/drawing/2014/main" id="{B17C9FAD-4B0A-4A43-889C-C68C521AD4CD}"/>
               </a:ext>
             </a:extLst>
           </p:cNvPr>
@@ -4863,7 +4863,7 @@
           <p:cNvPr id="31" name="">
             <a:extLst xmlns:a="http://schemas.openxmlformats.org/drawingml/2006/main">
               <a:ext uri="{FF2B5EF4-FFF2-40B4-BE49-F238E27FC236}">
-                <a16:creationId xmlns:a16="http://schemas.microsoft.com/office/drawing/2014/main" id="{6BBDE7A4-4FBB-4450-AF03-C6A8AAA3501B}"/>
+                <a16:creationId xmlns:a16="http://schemas.microsoft.com/office/drawing/2014/main" id="{351AD566-B58F-4930-98FC-15807FB9EE53}"/>
               </a:ext>
             </a:extLst>
           </p:cNvPr>
@@ -4918,7 +4918,7 @@
     </p:spTree>
     <p:extLst>
       <p:ext uri="{BB962C8B-B14F-4D97-AF65-F5344CB8AC3E}">
-        <p14:creationId xmlns:p14="http://schemas.microsoft.com/office/powerpoint/2010/main" val="117296597"/>
+        <p14:creationId xmlns:p14="http://schemas.microsoft.com/office/powerpoint/2010/main" val="1241135649"/>
       </p:ext>
     </p:extLst>
   </p:cSld>
@@ -4949,7 +4949,7 @@
           <p:cNvPr id="25" name="">
             <a:extLst xmlns:a="http://schemas.openxmlformats.org/drawingml/2006/main">
               <a:ext uri="{FF2B5EF4-FFF2-40B4-BE49-F238E27FC236}">
-                <a16:creationId xmlns:a16="http://schemas.microsoft.com/office/drawing/2014/main" id="{A6EFB4A7-9F15-4E66-BED5-9BBE716B6628}"/>
+                <a16:creationId xmlns:a16="http://schemas.microsoft.com/office/drawing/2014/main" id="{D7350C31-16C4-4E82-A611-18979101AB47}"/>
               </a:ext>
             </a:extLst>
           </p:cNvPr>
@@ -5006,7 +5006,7 @@
           <p:cNvPr id="2" name="">
             <a:extLst xmlns:a="http://schemas.openxmlformats.org/drawingml/2006/main">
               <a:ext uri="{FF2B5EF4-FFF2-40B4-BE49-F238E27FC236}">
-                <a16:creationId xmlns:a16="http://schemas.microsoft.com/office/drawing/2014/main" id="{876D3203-9BC5-4C43-8857-9AE41BEAB77D}"/>
+                <a16:creationId xmlns:a16="http://schemas.microsoft.com/office/drawing/2014/main" id="{5BB470D8-4767-42CC-9C77-108DE97C33B6}"/>
               </a:ext>
             </a:extLst>
           </p:cNvPr>
@@ -5067,7 +5067,7 @@
           <p:nvPr/>
         </p:nvPicPr>
         <p:blipFill>
-          <a:blip xmlns:r="http://schemas.openxmlformats.org/officeDocument/2006/relationships" xmlns:a="http://schemas.openxmlformats.org/drawingml/2006/main" r:embed="Rf33a77f38904491e"/>
+          <a:blip xmlns:r="http://schemas.openxmlformats.org/officeDocument/2006/relationships" xmlns:a="http://schemas.openxmlformats.org/drawingml/2006/main" r:embed="R6eb9587ddf7748af"/>
           <a:stretch xmlns:a="http://schemas.openxmlformats.org/drawingml/2006/main"/>
         </p:blipFill>
         <p:spPr>
@@ -5085,7 +5085,7 @@
           <p:cNvPr id="4" name="">
             <a:extLst xmlns:a="http://schemas.openxmlformats.org/drawingml/2006/main">
               <a:ext uri="{FF2B5EF4-FFF2-40B4-BE49-F238E27FC236}">
-                <a16:creationId xmlns:a16="http://schemas.microsoft.com/office/drawing/2014/main" id="{10D6B4CB-99C2-4474-8082-520484C88CF2}"/>
+                <a16:creationId xmlns:a16="http://schemas.microsoft.com/office/drawing/2014/main" id="{84BB8D8A-3BBA-44BE-AF72-413C4DE8D73C}"/>
               </a:ext>
             </a:extLst>
           </p:cNvPr>
@@ -5120,7 +5120,7 @@
           <p:cNvPr id="5" name="">
             <a:extLst xmlns:a="http://schemas.openxmlformats.org/drawingml/2006/main">
               <a:ext uri="{FF2B5EF4-FFF2-40B4-BE49-F238E27FC236}">
-                <a16:creationId xmlns:a16="http://schemas.microsoft.com/office/drawing/2014/main" id="{B2EB8DAA-68D1-4942-AE89-57F0A61481E3}"/>
+                <a16:creationId xmlns:a16="http://schemas.microsoft.com/office/drawing/2014/main" id="{0F4CA189-51A2-45B8-BB39-040D7B23E6A7}"/>
               </a:ext>
             </a:extLst>
           </p:cNvPr>
@@ -5177,7 +5177,7 @@
           <p:cNvPr id="6" name="">
             <a:extLst xmlns:a="http://schemas.openxmlformats.org/drawingml/2006/main">
               <a:ext uri="{FF2B5EF4-FFF2-40B4-BE49-F238E27FC236}">
-                <a16:creationId xmlns:a16="http://schemas.microsoft.com/office/drawing/2014/main" id="{2CE01EEC-3D82-41BE-AB0E-A59D205BEA71}"/>
+                <a16:creationId xmlns:a16="http://schemas.microsoft.com/office/drawing/2014/main" id="{D104A7B4-A9CF-4F27-9704-BB5298F5E453}"/>
               </a:ext>
             </a:extLst>
           </p:cNvPr>
@@ -5234,7 +5234,7 @@
           <p:cNvPr id="7" name="">
             <a:extLst xmlns:a="http://schemas.openxmlformats.org/drawingml/2006/main">
               <a:ext uri="{FF2B5EF4-FFF2-40B4-BE49-F238E27FC236}">
-                <a16:creationId xmlns:a16="http://schemas.microsoft.com/office/drawing/2014/main" id="{C2406251-A9FB-4803-A330-CD97E6A243A1}"/>
+                <a16:creationId xmlns:a16="http://schemas.microsoft.com/office/drawing/2014/main" id="{AEE84FDD-CA68-41D1-845C-A4E89D514811}"/>
               </a:ext>
             </a:extLst>
           </p:cNvPr>
@@ -5269,7 +5269,7 @@
           <p:cNvPr id="8" name="">
             <a:extLst xmlns:a="http://schemas.openxmlformats.org/drawingml/2006/main">
               <a:ext uri="{FF2B5EF4-FFF2-40B4-BE49-F238E27FC236}">
-                <a16:creationId xmlns:a16="http://schemas.microsoft.com/office/drawing/2014/main" id="{724F6A10-9359-473D-89BC-D30015AA6635}"/>
+                <a16:creationId xmlns:a16="http://schemas.microsoft.com/office/drawing/2014/main" id="{6BF695B8-B82B-4E2F-A465-DFD352500E43}"/>
               </a:ext>
             </a:extLst>
           </p:cNvPr>
@@ -5326,7 +5326,7 @@
           <p:cNvPr id="9" name="">
             <a:extLst xmlns:a="http://schemas.openxmlformats.org/drawingml/2006/main">
               <a:ext uri="{FF2B5EF4-FFF2-40B4-BE49-F238E27FC236}">
-                <a16:creationId xmlns:a16="http://schemas.microsoft.com/office/drawing/2014/main" id="{6EF7F2A7-93C7-4931-B119-D7F338BD17A1}"/>
+                <a16:creationId xmlns:a16="http://schemas.microsoft.com/office/drawing/2014/main" id="{A7639178-657D-4F50-9C9A-E5E02E4D9A00}"/>
               </a:ext>
             </a:extLst>
           </p:cNvPr>
@@ -5383,7 +5383,7 @@
           <p:cNvPr id="10" name="">
             <a:extLst xmlns:a="http://schemas.openxmlformats.org/drawingml/2006/main">
               <a:ext uri="{FF2B5EF4-FFF2-40B4-BE49-F238E27FC236}">
-                <a16:creationId xmlns:a16="http://schemas.microsoft.com/office/drawing/2014/main" id="{92AA32C6-E027-4A79-99F0-D9444D67AFEE}"/>
+                <a16:creationId xmlns:a16="http://schemas.microsoft.com/office/drawing/2014/main" id="{D9A1F681-8009-4F06-B2AB-AD72F3227B5A}"/>
               </a:ext>
             </a:extLst>
           </p:cNvPr>
@@ -5418,7 +5418,7 @@
           <p:cNvPr id="11" name="">
             <a:extLst xmlns:a="http://schemas.openxmlformats.org/drawingml/2006/main">
               <a:ext uri="{FF2B5EF4-FFF2-40B4-BE49-F238E27FC236}">
-                <a16:creationId xmlns:a16="http://schemas.microsoft.com/office/drawing/2014/main" id="{EDC66CF1-875A-41FE-9D9D-E8AC0775BAE6}"/>
+                <a16:creationId xmlns:a16="http://schemas.microsoft.com/office/drawing/2014/main" id="{16C005C5-589F-46BC-9D45-FB74883783B0}"/>
               </a:ext>
             </a:extLst>
           </p:cNvPr>
@@ -5475,7 +5475,7 @@
           <p:cNvPr id="12" name="">
             <a:extLst xmlns:a="http://schemas.openxmlformats.org/drawingml/2006/main">
               <a:ext uri="{FF2B5EF4-FFF2-40B4-BE49-F238E27FC236}">
-                <a16:creationId xmlns:a16="http://schemas.microsoft.com/office/drawing/2014/main" id="{A48D19A4-E6C1-4CF0-85A9-A8EBBF6B44FD}"/>
+                <a16:creationId xmlns:a16="http://schemas.microsoft.com/office/drawing/2014/main" id="{F17C11AD-41BE-4B29-A653-19D6B4D27BE2}"/>
               </a:ext>
             </a:extLst>
           </p:cNvPr>
@@ -5532,7 +5532,7 @@
           <p:cNvPr id="13" name="">
             <a:extLst xmlns:a="http://schemas.openxmlformats.org/drawingml/2006/main">
               <a:ext uri="{FF2B5EF4-FFF2-40B4-BE49-F238E27FC236}">
-                <a16:creationId xmlns:a16="http://schemas.microsoft.com/office/drawing/2014/main" id="{AF984010-C1FB-44DA-B6DE-93BED7348240}"/>
+                <a16:creationId xmlns:a16="http://schemas.microsoft.com/office/drawing/2014/main" id="{A667EAA3-9056-4ED5-ACDD-A6FB30DBEA6B}"/>
               </a:ext>
             </a:extLst>
           </p:cNvPr>
@@ -5567,7 +5567,7 @@
           <p:cNvPr id="14" name="">
             <a:extLst xmlns:a="http://schemas.openxmlformats.org/drawingml/2006/main">
               <a:ext uri="{FF2B5EF4-FFF2-40B4-BE49-F238E27FC236}">
-                <a16:creationId xmlns:a16="http://schemas.microsoft.com/office/drawing/2014/main" id="{D38AEEA4-FC9F-4DD9-939D-AD3914C181AC}"/>
+                <a16:creationId xmlns:a16="http://schemas.microsoft.com/office/drawing/2014/main" id="{F1CF685D-3E85-4E00-A6DA-76440A1BE750}"/>
               </a:ext>
             </a:extLst>
           </p:cNvPr>
@@ -5624,7 +5624,7 @@
           <p:cNvPr id="15" name="">
             <a:extLst xmlns:a="http://schemas.openxmlformats.org/drawingml/2006/main">
               <a:ext uri="{FF2B5EF4-FFF2-40B4-BE49-F238E27FC236}">
-                <a16:creationId xmlns:a16="http://schemas.microsoft.com/office/drawing/2014/main" id="{7F61DD38-6721-4F30-8407-B27229FDC200}"/>
+                <a16:creationId xmlns:a16="http://schemas.microsoft.com/office/drawing/2014/main" id="{F4B60EFA-63FF-4192-A4F3-6742486FD053}"/>
               </a:ext>
             </a:extLst>
           </p:cNvPr>
@@ -5681,7 +5681,7 @@
           <p:cNvPr id="16" name="">
             <a:extLst xmlns:a="http://schemas.openxmlformats.org/drawingml/2006/main">
               <a:ext uri="{FF2B5EF4-FFF2-40B4-BE49-F238E27FC236}">
-                <a16:creationId xmlns:a16="http://schemas.microsoft.com/office/drawing/2014/main" id="{302BE803-1F6F-49B0-B7A8-C0CF3B5A440A}"/>
+                <a16:creationId xmlns:a16="http://schemas.microsoft.com/office/drawing/2014/main" id="{014E07D6-A83F-4154-997C-6EE1E4978CA2}"/>
               </a:ext>
             </a:extLst>
           </p:cNvPr>
@@ -5716,7 +5716,7 @@
           <p:cNvPr id="17" name="">
             <a:extLst xmlns:a="http://schemas.openxmlformats.org/drawingml/2006/main">
               <a:ext uri="{FF2B5EF4-FFF2-40B4-BE49-F238E27FC236}">
-                <a16:creationId xmlns:a16="http://schemas.microsoft.com/office/drawing/2014/main" id="{AF7EC388-C968-4C5E-9543-225991F62319}"/>
+                <a16:creationId xmlns:a16="http://schemas.microsoft.com/office/drawing/2014/main" id="{39A2A9E4-DABF-4FEC-A711-2976C73A7D84}"/>
               </a:ext>
             </a:extLst>
           </p:cNvPr>
@@ -5773,7 +5773,7 @@
           <p:cNvPr id="18" name="">
             <a:extLst xmlns:a="http://schemas.openxmlformats.org/drawingml/2006/main">
               <a:ext uri="{FF2B5EF4-FFF2-40B4-BE49-F238E27FC236}">
-                <a16:creationId xmlns:a16="http://schemas.microsoft.com/office/drawing/2014/main" id="{977F002B-29CD-4B08-ACD1-3540F49E3FC1}"/>
+                <a16:creationId xmlns:a16="http://schemas.microsoft.com/office/drawing/2014/main" id="{A701C39C-7CC7-4733-9447-89273C91BB21}"/>
               </a:ext>
             </a:extLst>
           </p:cNvPr>
@@ -5830,7 +5830,7 @@
           <p:cNvPr id="19" name="">
             <a:extLst xmlns:a="http://schemas.openxmlformats.org/drawingml/2006/main">
               <a:ext uri="{FF2B5EF4-FFF2-40B4-BE49-F238E27FC236}">
-                <a16:creationId xmlns:a16="http://schemas.microsoft.com/office/drawing/2014/main" id="{0DE8B913-6638-415B-A54F-D3C2D286F940}"/>
+                <a16:creationId xmlns:a16="http://schemas.microsoft.com/office/drawing/2014/main" id="{B72AE7DD-4259-4907-BA85-3041A8847935}"/>
               </a:ext>
             </a:extLst>
           </p:cNvPr>
@@ -5865,7 +5865,7 @@
           <p:cNvPr id="20" name="">
             <a:extLst xmlns:a="http://schemas.openxmlformats.org/drawingml/2006/main">
               <a:ext uri="{FF2B5EF4-FFF2-40B4-BE49-F238E27FC236}">
-                <a16:creationId xmlns:a16="http://schemas.microsoft.com/office/drawing/2014/main" id="{51D809B5-504C-40AA-836B-03354D3DD07C}"/>
+                <a16:creationId xmlns:a16="http://schemas.microsoft.com/office/drawing/2014/main" id="{83CACCDA-D6D1-4A66-9C43-079DF034FAB5}"/>
               </a:ext>
             </a:extLst>
           </p:cNvPr>
@@ -5922,7 +5922,7 @@
           <p:cNvPr id="21" name="">
             <a:extLst xmlns:a="http://schemas.openxmlformats.org/drawingml/2006/main">
               <a:ext uri="{FF2B5EF4-FFF2-40B4-BE49-F238E27FC236}">
-                <a16:creationId xmlns:a16="http://schemas.microsoft.com/office/drawing/2014/main" id="{CD1BCE4D-8F14-49DE-A513-F82447AC985E}"/>
+                <a16:creationId xmlns:a16="http://schemas.microsoft.com/office/drawing/2014/main" id="{0F43BEFD-2F91-43D9-940E-0B2758AE8BCF}"/>
               </a:ext>
             </a:extLst>
           </p:cNvPr>
@@ -5983,7 +5983,7 @@
           <p:nvPr/>
         </p:nvPicPr>
         <p:blipFill>
-          <a:blip xmlns:r="http://schemas.openxmlformats.org/officeDocument/2006/relationships" xmlns:a="http://schemas.openxmlformats.org/drawingml/2006/main" r:embed="Rd47d29df6b89464f"/>
+          <a:blip xmlns:r="http://schemas.openxmlformats.org/officeDocument/2006/relationships" xmlns:a="http://schemas.openxmlformats.org/drawingml/2006/main" r:embed="R932d127d3ff646d3"/>
           <a:stretch xmlns:a="http://schemas.openxmlformats.org/drawingml/2006/main"/>
         </p:blipFill>
         <p:spPr>
@@ -6001,7 +6001,7 @@
           <p:cNvPr id="23" name="">
             <a:extLst xmlns:a="http://schemas.openxmlformats.org/drawingml/2006/main">
               <a:ext uri="{FF2B5EF4-FFF2-40B4-BE49-F238E27FC236}">
-                <a16:creationId xmlns:a16="http://schemas.microsoft.com/office/drawing/2014/main" id="{6C0E0263-B044-488B-B875-C034BBB5456C}"/>
+                <a16:creationId xmlns:a16="http://schemas.microsoft.com/office/drawing/2014/main" id="{4E7EB7BB-6C5E-4F9A-AF12-815E2D0F988F}"/>
               </a:ext>
             </a:extLst>
           </p:cNvPr>
@@ -6058,7 +6058,7 @@
           <p:cNvPr id="24" name="">
             <a:extLst xmlns:a="http://schemas.openxmlformats.org/drawingml/2006/main">
               <a:ext uri="{FF2B5EF4-FFF2-40B4-BE49-F238E27FC236}">
-                <a16:creationId xmlns:a16="http://schemas.microsoft.com/office/drawing/2014/main" id="{A8E42BA7-8E7E-44C8-83E6-9AA12EBBE758}"/>
+                <a16:creationId xmlns:a16="http://schemas.microsoft.com/office/drawing/2014/main" id="{F3D3D7A5-39FA-4E67-9075-B3978F27ABB2}"/>
               </a:ext>
             </a:extLst>
           </p:cNvPr>
@@ -6113,7 +6113,7 @@
     </p:spTree>
     <p:extLst>
       <p:ext uri="{BB962C8B-B14F-4D97-AF65-F5344CB8AC3E}">
-        <p14:creationId xmlns:p14="http://schemas.microsoft.com/office/powerpoint/2010/main" val="125054141"/>
+        <p14:creationId xmlns:p14="http://schemas.microsoft.com/office/powerpoint/2010/main" val="29713706"/>
       </p:ext>
     </p:extLst>
   </p:cSld>
@@ -6144,7 +6144,7 @@
           <p:cNvPr id="31" name="">
             <a:extLst xmlns:a="http://schemas.openxmlformats.org/drawingml/2006/main">
               <a:ext uri="{FF2B5EF4-FFF2-40B4-BE49-F238E27FC236}">
-                <a16:creationId xmlns:a16="http://schemas.microsoft.com/office/drawing/2014/main" id="{3D12B706-0788-4007-94ED-5C26600D33A6}"/>
+                <a16:creationId xmlns:a16="http://schemas.microsoft.com/office/drawing/2014/main" id="{EDF53AE0-23C2-4558-AF96-AF094C9145E1}"/>
               </a:ext>
             </a:extLst>
           </p:cNvPr>
@@ -6201,7 +6201,7 @@
           <p:cNvPr id="2" name="">
             <a:extLst xmlns:a="http://schemas.openxmlformats.org/drawingml/2006/main">
               <a:ext uri="{FF2B5EF4-FFF2-40B4-BE49-F238E27FC236}">
-                <a16:creationId xmlns:a16="http://schemas.microsoft.com/office/drawing/2014/main" id="{38DCDA75-6FF5-45A9-80D3-19F5AF3DC065}"/>
+                <a16:creationId xmlns:a16="http://schemas.microsoft.com/office/drawing/2014/main" id="{E07F7AC4-A583-4B01-B688-8CD154841CFF}"/>
               </a:ext>
             </a:extLst>
           </p:cNvPr>
@@ -6262,7 +6262,7 @@
           <p:nvPr/>
         </p:nvPicPr>
         <p:blipFill>
-          <a:blip xmlns:r="http://schemas.openxmlformats.org/officeDocument/2006/relationships" xmlns:a="http://schemas.openxmlformats.org/drawingml/2006/main" r:embed="R141dd6f7feac4218"/>
+          <a:blip xmlns:r="http://schemas.openxmlformats.org/officeDocument/2006/relationships" xmlns:a="http://schemas.openxmlformats.org/drawingml/2006/main" r:embed="Rf0b402aff93044c8"/>
           <a:stretch xmlns:a="http://schemas.openxmlformats.org/drawingml/2006/main"/>
         </p:blipFill>
         <p:spPr>
@@ -6280,7 +6280,7 @@
           <p:cNvPr id="4" name="">
             <a:extLst xmlns:a="http://schemas.openxmlformats.org/drawingml/2006/main">
               <a:ext uri="{FF2B5EF4-FFF2-40B4-BE49-F238E27FC236}">
-                <a16:creationId xmlns:a16="http://schemas.microsoft.com/office/drawing/2014/main" id="{B4E02C1B-2148-4656-9BC7-B7FA4707725E}"/>
+                <a16:creationId xmlns:a16="http://schemas.microsoft.com/office/drawing/2014/main" id="{33B8F47A-FE5C-4976-B395-8DA5A9471615}"/>
               </a:ext>
             </a:extLst>
           </p:cNvPr>
@@ -6337,7 +6337,7 @@
           <p:cNvPr id="5" name="">
             <a:extLst xmlns:a="http://schemas.openxmlformats.org/drawingml/2006/main">
               <a:ext uri="{FF2B5EF4-FFF2-40B4-BE49-F238E27FC236}">
-                <a16:creationId xmlns:a16="http://schemas.microsoft.com/office/drawing/2014/main" id="{C8A40664-5D5C-45D7-9D4D-D1FD6E6E5BCD}"/>
+                <a16:creationId xmlns:a16="http://schemas.microsoft.com/office/drawing/2014/main" id="{9059CB59-1B3C-4492-AAD5-535027DF11B7}"/>
               </a:ext>
             </a:extLst>
           </p:cNvPr>
@@ -6394,7 +6394,7 @@
           <p:cNvPr id="6" name="">
             <a:extLst xmlns:a="http://schemas.openxmlformats.org/drawingml/2006/main">
               <a:ext uri="{FF2B5EF4-FFF2-40B4-BE49-F238E27FC236}">
-                <a16:creationId xmlns:a16="http://schemas.microsoft.com/office/drawing/2014/main" id="{0D3B3161-3CF8-4AD7-9A7D-74086186234B}"/>
+                <a16:creationId xmlns:a16="http://schemas.microsoft.com/office/drawing/2014/main" id="{481124FA-F967-47EA-8D60-459E0388ECE3}"/>
               </a:ext>
             </a:extLst>
           </p:cNvPr>
@@ -6451,7 +6451,7 @@
           <p:cNvPr id="7" name="">
             <a:extLst xmlns:a="http://schemas.openxmlformats.org/drawingml/2006/main">
               <a:ext uri="{FF2B5EF4-FFF2-40B4-BE49-F238E27FC236}">
-                <a16:creationId xmlns:a16="http://schemas.microsoft.com/office/drawing/2014/main" id="{973B01D9-14F6-4D4D-8DC3-5189C2E0C488}"/>
+                <a16:creationId xmlns:a16="http://schemas.microsoft.com/office/drawing/2014/main" id="{DB8E5CCA-F277-40EA-983A-3491C30B9BBE}"/>
               </a:ext>
             </a:extLst>
           </p:cNvPr>
@@ -6481,7 +6481,7 @@
           <p:cNvPr id="8" name="">
             <a:extLst xmlns:a="http://schemas.openxmlformats.org/drawingml/2006/main">
               <a:ext uri="{FF2B5EF4-FFF2-40B4-BE49-F238E27FC236}">
-                <a16:creationId xmlns:a16="http://schemas.microsoft.com/office/drawing/2014/main" id="{51C5BE52-14C2-4A0D-88CE-3722CBC192F3}"/>
+                <a16:creationId xmlns:a16="http://schemas.microsoft.com/office/drawing/2014/main" id="{90CB7F4B-2207-4545-B37D-50BB107C0708}"/>
               </a:ext>
             </a:extLst>
           </p:cNvPr>
@@ -6538,7 +6538,7 @@
           <p:cNvPr id="9" name="">
             <a:extLst xmlns:a="http://schemas.openxmlformats.org/drawingml/2006/main">
               <a:ext uri="{FF2B5EF4-FFF2-40B4-BE49-F238E27FC236}">
-                <a16:creationId xmlns:a16="http://schemas.microsoft.com/office/drawing/2014/main" id="{8D4438F9-FEDB-4896-BC1C-0F50F4553374}"/>
+                <a16:creationId xmlns:a16="http://schemas.microsoft.com/office/drawing/2014/main" id="{9B12C50E-E2BA-4279-B4E7-36DF521BD72C}"/>
               </a:ext>
             </a:extLst>
           </p:cNvPr>
@@ -6568,7 +6568,7 @@
           <p:cNvPr id="10" name="">
             <a:extLst xmlns:a="http://schemas.openxmlformats.org/drawingml/2006/main">
               <a:ext uri="{FF2B5EF4-FFF2-40B4-BE49-F238E27FC236}">
-                <a16:creationId xmlns:a16="http://schemas.microsoft.com/office/drawing/2014/main" id="{C631ED6C-FD08-4EAA-B1F2-5E92FA2872C2}"/>
+                <a16:creationId xmlns:a16="http://schemas.microsoft.com/office/drawing/2014/main" id="{A9DB40D5-9325-438D-8A83-4E7A9CC1A2F9}"/>
               </a:ext>
             </a:extLst>
           </p:cNvPr>
@@ -6625,7 +6625,7 @@
           <p:cNvPr id="11" name="">
             <a:extLst xmlns:a="http://schemas.openxmlformats.org/drawingml/2006/main">
               <a:ext uri="{FF2B5EF4-FFF2-40B4-BE49-F238E27FC236}">
-                <a16:creationId xmlns:a16="http://schemas.microsoft.com/office/drawing/2014/main" id="{21EC9D0F-8A3B-4397-B316-25292F4411A9}"/>
+                <a16:creationId xmlns:a16="http://schemas.microsoft.com/office/drawing/2014/main" id="{76819F1A-9A4D-421D-8964-C1135D555900}"/>
               </a:ext>
             </a:extLst>
           </p:cNvPr>
@@ -6655,7 +6655,7 @@
           <p:cNvPr id="12" name="">
             <a:extLst xmlns:a="http://schemas.openxmlformats.org/drawingml/2006/main">
               <a:ext uri="{FF2B5EF4-FFF2-40B4-BE49-F238E27FC236}">
-                <a16:creationId xmlns:a16="http://schemas.microsoft.com/office/drawing/2014/main" id="{8151FDE2-1782-4449-863A-1BDF8F5BD971}"/>
+                <a16:creationId xmlns:a16="http://schemas.microsoft.com/office/drawing/2014/main" id="{3AE4BABA-DE51-4ABC-9FF7-F62CC7B060C8}"/>
               </a:ext>
             </a:extLst>
           </p:cNvPr>
@@ -6712,7 +6712,7 @@
           <p:cNvPr id="13" name="">
             <a:extLst xmlns:a="http://schemas.openxmlformats.org/drawingml/2006/main">
               <a:ext uri="{FF2B5EF4-FFF2-40B4-BE49-F238E27FC236}">
-                <a16:creationId xmlns:a16="http://schemas.microsoft.com/office/drawing/2014/main" id="{C4D6D41C-5C35-4F3C-9723-BFF1C3614924}"/>
+                <a16:creationId xmlns:a16="http://schemas.microsoft.com/office/drawing/2014/main" id="{B1F1248B-BFFF-4CB0-B2E7-0477C0E0D400}"/>
               </a:ext>
             </a:extLst>
           </p:cNvPr>
@@ -6769,7 +6769,7 @@
           <p:cNvPr id="14" name="">
             <a:extLst xmlns:a="http://schemas.openxmlformats.org/drawingml/2006/main">
               <a:ext uri="{FF2B5EF4-FFF2-40B4-BE49-F238E27FC236}">
-                <a16:creationId xmlns:a16="http://schemas.microsoft.com/office/drawing/2014/main" id="{6C103716-AA1D-416B-8F44-7040AA0BF1D2}"/>
+                <a16:creationId xmlns:a16="http://schemas.microsoft.com/office/drawing/2014/main" id="{D36BF4F6-176D-4317-8BD7-7AF818654C56}"/>
               </a:ext>
             </a:extLst>
           </p:cNvPr>
@@ -6826,7 +6826,7 @@
           <p:cNvPr id="15" name="">
             <a:extLst xmlns:a="http://schemas.openxmlformats.org/drawingml/2006/main">
               <a:ext uri="{FF2B5EF4-FFF2-40B4-BE49-F238E27FC236}">
-                <a16:creationId xmlns:a16="http://schemas.microsoft.com/office/drawing/2014/main" id="{496075B9-AE12-4203-A999-0EA572206573}"/>
+                <a16:creationId xmlns:a16="http://schemas.microsoft.com/office/drawing/2014/main" id="{268AB10E-8F1C-4112-A292-FD3FA8AC724D}"/>
               </a:ext>
             </a:extLst>
           </p:cNvPr>
@@ -6856,7 +6856,7 @@
           <p:cNvPr id="16" name="">
             <a:extLst xmlns:a="http://schemas.openxmlformats.org/drawingml/2006/main">
               <a:ext uri="{FF2B5EF4-FFF2-40B4-BE49-F238E27FC236}">
-                <a16:creationId xmlns:a16="http://schemas.microsoft.com/office/drawing/2014/main" id="{A360654A-829E-474A-A9A8-402608855863}"/>
+                <a16:creationId xmlns:a16="http://schemas.microsoft.com/office/drawing/2014/main" id="{45343B6F-6084-4215-9C80-FBA72A83C41C}"/>
               </a:ext>
             </a:extLst>
           </p:cNvPr>
@@ -6913,7 +6913,7 @@
           <p:cNvPr id="17" name="">
             <a:extLst xmlns:a="http://schemas.openxmlformats.org/drawingml/2006/main">
               <a:ext uri="{FF2B5EF4-FFF2-40B4-BE49-F238E27FC236}">
-                <a16:creationId xmlns:a16="http://schemas.microsoft.com/office/drawing/2014/main" id="{989F49E6-F0C8-4F16-AA3D-20D5808804BF}"/>
+                <a16:creationId xmlns:a16="http://schemas.microsoft.com/office/drawing/2014/main" id="{2341A666-D4BC-497C-B309-F4045EBCB49F}"/>
               </a:ext>
             </a:extLst>
           </p:cNvPr>
@@ -6943,7 +6943,7 @@
           <p:cNvPr id="18" name="">
             <a:extLst xmlns:a="http://schemas.openxmlformats.org/drawingml/2006/main">
               <a:ext uri="{FF2B5EF4-FFF2-40B4-BE49-F238E27FC236}">
-                <a16:creationId xmlns:a16="http://schemas.microsoft.com/office/drawing/2014/main" id="{04F6A85C-1E8A-40FC-A130-968F4EE8181B}"/>
+                <a16:creationId xmlns:a16="http://schemas.microsoft.com/office/drawing/2014/main" id="{5A5F8189-F83F-4CCD-8803-494AE4DAAA95}"/>
               </a:ext>
             </a:extLst>
           </p:cNvPr>
@@ -7000,7 +7000,7 @@
           <p:cNvPr id="19" name="">
             <a:extLst xmlns:a="http://schemas.openxmlformats.org/drawingml/2006/main">
               <a:ext uri="{FF2B5EF4-FFF2-40B4-BE49-F238E27FC236}">
-                <a16:creationId xmlns:a16="http://schemas.microsoft.com/office/drawing/2014/main" id="{B77D788B-DCC5-4F0F-85C6-82E7FF51D2C0}"/>
+                <a16:creationId xmlns:a16="http://schemas.microsoft.com/office/drawing/2014/main" id="{876CCFF2-40F8-47F4-AE0D-D74E59FCBFC6}"/>
               </a:ext>
             </a:extLst>
           </p:cNvPr>
@@ -7030,7 +7030,7 @@
           <p:cNvPr id="20" name="">
             <a:extLst xmlns:a="http://schemas.openxmlformats.org/drawingml/2006/main">
               <a:ext uri="{FF2B5EF4-FFF2-40B4-BE49-F238E27FC236}">
-                <a16:creationId xmlns:a16="http://schemas.microsoft.com/office/drawing/2014/main" id="{9ED509FD-D8C0-45DD-AC44-3B4915472DB5}"/>
+                <a16:creationId xmlns:a16="http://schemas.microsoft.com/office/drawing/2014/main" id="{8B0C4656-8FBB-4BA4-8A8C-5D3DFC47493D}"/>
               </a:ext>
             </a:extLst>
           </p:cNvPr>
@@ -7087,7 +7087,7 @@
           <p:cNvPr id="21" name="">
             <a:extLst xmlns:a="http://schemas.openxmlformats.org/drawingml/2006/main">
               <a:ext uri="{FF2B5EF4-FFF2-40B4-BE49-F238E27FC236}">
-                <a16:creationId xmlns:a16="http://schemas.microsoft.com/office/drawing/2014/main" id="{E43D2CD8-091E-4D76-9922-E92A24DD232B}"/>
+                <a16:creationId xmlns:a16="http://schemas.microsoft.com/office/drawing/2014/main" id="{FB234EBC-1E59-4D21-9437-888A4913A261}"/>
               </a:ext>
             </a:extLst>
           </p:cNvPr>
@@ -7144,7 +7144,7 @@
           <p:cNvPr id="22" name="">
             <a:extLst xmlns:a="http://schemas.openxmlformats.org/drawingml/2006/main">
               <a:ext uri="{FF2B5EF4-FFF2-40B4-BE49-F238E27FC236}">
-                <a16:creationId xmlns:a16="http://schemas.microsoft.com/office/drawing/2014/main" id="{6C9EE1C6-6E36-483B-8D32-4A6FE4FBDF13}"/>
+                <a16:creationId xmlns:a16="http://schemas.microsoft.com/office/drawing/2014/main" id="{A8AF3751-12F3-4672-A7FC-AE449011028B}"/>
               </a:ext>
             </a:extLst>
           </p:cNvPr>
@@ -7201,7 +7201,7 @@
           <p:cNvPr id="23" name="">
             <a:extLst xmlns:a="http://schemas.openxmlformats.org/drawingml/2006/main">
               <a:ext uri="{FF2B5EF4-FFF2-40B4-BE49-F238E27FC236}">
-                <a16:creationId xmlns:a16="http://schemas.microsoft.com/office/drawing/2014/main" id="{AF6E7918-D9E3-441D-98CB-FF14F2EFCA04}"/>
+                <a16:creationId xmlns:a16="http://schemas.microsoft.com/office/drawing/2014/main" id="{26DEE826-E21C-45D7-87CF-6239A1D474D8}"/>
               </a:ext>
             </a:extLst>
           </p:cNvPr>
@@ -7231,7 +7231,7 @@
           <p:cNvPr id="24" name="">
             <a:extLst xmlns:a="http://schemas.openxmlformats.org/drawingml/2006/main">
               <a:ext uri="{FF2B5EF4-FFF2-40B4-BE49-F238E27FC236}">
-                <a16:creationId xmlns:a16="http://schemas.microsoft.com/office/drawing/2014/main" id="{6E3DC10B-18AB-45A3-9401-5D1DC105E029}"/>
+                <a16:creationId xmlns:a16="http://schemas.microsoft.com/office/drawing/2014/main" id="{631EB60B-ECBB-4F41-A83A-C036F4F5EC63}"/>
               </a:ext>
             </a:extLst>
           </p:cNvPr>
@@ -7288,7 +7288,7 @@
           <p:cNvPr id="25" name="">
             <a:extLst xmlns:a="http://schemas.openxmlformats.org/drawingml/2006/main">
               <a:ext uri="{FF2B5EF4-FFF2-40B4-BE49-F238E27FC236}">
-                <a16:creationId xmlns:a16="http://schemas.microsoft.com/office/drawing/2014/main" id="{089177DA-7475-4905-BC7F-9B3EF5787A6F}"/>
+                <a16:creationId xmlns:a16="http://schemas.microsoft.com/office/drawing/2014/main" id="{6149A917-7EFB-4DC2-B9CB-55570009DE1F}"/>
               </a:ext>
             </a:extLst>
           </p:cNvPr>
@@ -7318,7 +7318,7 @@
           <p:cNvPr id="26" name="">
             <a:extLst xmlns:a="http://schemas.openxmlformats.org/drawingml/2006/main">
               <a:ext uri="{FF2B5EF4-FFF2-40B4-BE49-F238E27FC236}">
-                <a16:creationId xmlns:a16="http://schemas.microsoft.com/office/drawing/2014/main" id="{39BDFBB3-6067-4A41-913F-D2CCD8A503A8}"/>
+                <a16:creationId xmlns:a16="http://schemas.microsoft.com/office/drawing/2014/main" id="{E1DB7271-9F9E-4442-8CCD-F4A472AA25B9}"/>
               </a:ext>
             </a:extLst>
           </p:cNvPr>
@@ -7375,7 +7375,7 @@
           <p:cNvPr id="27" name="">
             <a:extLst xmlns:a="http://schemas.openxmlformats.org/drawingml/2006/main">
               <a:ext uri="{FF2B5EF4-FFF2-40B4-BE49-F238E27FC236}">
-                <a16:creationId xmlns:a16="http://schemas.microsoft.com/office/drawing/2014/main" id="{ACA76BD6-8C6C-4AD5-9604-4C9D3A989CF2}"/>
+                <a16:creationId xmlns:a16="http://schemas.microsoft.com/office/drawing/2014/main" id="{8FFAA669-FB0D-4E4E-815A-84692764C7BB}"/>
               </a:ext>
             </a:extLst>
           </p:cNvPr>
@@ -7405,7 +7405,7 @@
           <p:cNvPr id="28" name="">
             <a:extLst xmlns:a="http://schemas.openxmlformats.org/drawingml/2006/main">
               <a:ext uri="{FF2B5EF4-FFF2-40B4-BE49-F238E27FC236}">
-                <a16:creationId xmlns:a16="http://schemas.microsoft.com/office/drawing/2014/main" id="{DF9CF89F-AC87-4111-BE52-B574564A2003}"/>
+                <a16:creationId xmlns:a16="http://schemas.microsoft.com/office/drawing/2014/main" id="{43A34A3D-EC76-41CC-9129-8B15A9B5ABAA}"/>
               </a:ext>
             </a:extLst>
           </p:cNvPr>
@@ -7462,7 +7462,7 @@
           <p:cNvPr id="29" name="">
             <a:extLst xmlns:a="http://schemas.openxmlformats.org/drawingml/2006/main">
               <a:ext uri="{FF2B5EF4-FFF2-40B4-BE49-F238E27FC236}">
-                <a16:creationId xmlns:a16="http://schemas.microsoft.com/office/drawing/2014/main" id="{ECCA5C41-D0A7-407B-A949-639790C9F755}"/>
+                <a16:creationId xmlns:a16="http://schemas.microsoft.com/office/drawing/2014/main" id="{A1AAE134-916B-4B16-95BA-6455E1E2AF20}"/>
               </a:ext>
             </a:extLst>
           </p:cNvPr>
@@ -7519,7 +7519,7 @@
           <p:cNvPr id="30" name="">
             <a:extLst xmlns:a="http://schemas.openxmlformats.org/drawingml/2006/main">
               <a:ext uri="{FF2B5EF4-FFF2-40B4-BE49-F238E27FC236}">
-                <a16:creationId xmlns:a16="http://schemas.microsoft.com/office/drawing/2014/main" id="{1FEE5569-8588-450A-ACF5-D76CC740478E}"/>
+                <a16:creationId xmlns:a16="http://schemas.microsoft.com/office/drawing/2014/main" id="{EFD87404-C788-488B-91CD-B720DFEBAA77}"/>
               </a:ext>
             </a:extLst>
           </p:cNvPr>
@@ -7574,7 +7574,7 @@
     </p:spTree>
     <p:extLst>
       <p:ext uri="{BB962C8B-B14F-4D97-AF65-F5344CB8AC3E}">
-        <p14:creationId xmlns:p14="http://schemas.microsoft.com/office/powerpoint/2010/main" val="55133701"/>
+        <p14:creationId xmlns:p14="http://schemas.microsoft.com/office/powerpoint/2010/main" val="1044018667"/>
       </p:ext>
     </p:extLst>
   </p:cSld>
@@ -7605,7 +7605,7 @@
           <p:cNvPr id="23" name="">
             <a:extLst xmlns:a="http://schemas.openxmlformats.org/drawingml/2006/main">
               <a:ext uri="{FF2B5EF4-FFF2-40B4-BE49-F238E27FC236}">
-                <a16:creationId xmlns:a16="http://schemas.microsoft.com/office/drawing/2014/main" id="{9BECAAC0-7F16-43CB-83F6-228CEFF1F16C}"/>
+                <a16:creationId xmlns:a16="http://schemas.microsoft.com/office/drawing/2014/main" id="{DD9C9F61-15C5-4EAC-A50C-93A78C292FDB}"/>
               </a:ext>
             </a:extLst>
           </p:cNvPr>
@@ -7662,7 +7662,7 @@
           <p:cNvPr id="2" name="">
             <a:extLst xmlns:a="http://schemas.openxmlformats.org/drawingml/2006/main">
               <a:ext uri="{FF2B5EF4-FFF2-40B4-BE49-F238E27FC236}">
-                <a16:creationId xmlns:a16="http://schemas.microsoft.com/office/drawing/2014/main" id="{63D8C352-C8D8-46B7-9983-ADFAF7B263AF}"/>
+                <a16:creationId xmlns:a16="http://schemas.microsoft.com/office/drawing/2014/main" id="{D5D47B5E-6616-4020-90A9-AF3975BB6F54}"/>
               </a:ext>
             </a:extLst>
           </p:cNvPr>
@@ -7723,7 +7723,7 @@
           <p:nvPr/>
         </p:nvPicPr>
         <p:blipFill>
-          <a:blip xmlns:r="http://schemas.openxmlformats.org/officeDocument/2006/relationships" xmlns:a="http://schemas.openxmlformats.org/drawingml/2006/main" r:embed="Rbc0fce89d49f4103"/>
+          <a:blip xmlns:r="http://schemas.openxmlformats.org/officeDocument/2006/relationships" xmlns:a="http://schemas.openxmlformats.org/drawingml/2006/main" r:embed="R2a447d4bb4844e7e"/>
           <a:stretch xmlns:a="http://schemas.openxmlformats.org/drawingml/2006/main"/>
         </p:blipFill>
         <p:spPr>
@@ -7741,7 +7741,7 @@
           <p:cNvPr id="4" name="">
             <a:extLst xmlns:a="http://schemas.openxmlformats.org/drawingml/2006/main">
               <a:ext uri="{FF2B5EF4-FFF2-40B4-BE49-F238E27FC236}">
-                <a16:creationId xmlns:a16="http://schemas.microsoft.com/office/drawing/2014/main" id="{724B4EBE-FEA1-452F-8717-E78DC62047CB}"/>
+                <a16:creationId xmlns:a16="http://schemas.microsoft.com/office/drawing/2014/main" id="{18D6D53E-D72C-4540-AAA0-3F06CC572318}"/>
               </a:ext>
             </a:extLst>
           </p:cNvPr>
@@ -7776,7 +7776,7 @@
           <p:cNvPr id="5" name="">
             <a:extLst xmlns:a="http://schemas.openxmlformats.org/drawingml/2006/main">
               <a:ext uri="{FF2B5EF4-FFF2-40B4-BE49-F238E27FC236}">
-                <a16:creationId xmlns:a16="http://schemas.microsoft.com/office/drawing/2014/main" id="{AFECF3D9-8C02-43D4-AA60-8C25282B3EAC}"/>
+                <a16:creationId xmlns:a16="http://schemas.microsoft.com/office/drawing/2014/main" id="{5BA03214-4CA3-443C-A2C1-9B1E9F013B76}"/>
               </a:ext>
             </a:extLst>
           </p:cNvPr>
@@ -7833,7 +7833,7 @@
           <p:cNvPr id="6" name="">
             <a:extLst xmlns:a="http://schemas.openxmlformats.org/drawingml/2006/main">
               <a:ext uri="{FF2B5EF4-FFF2-40B4-BE49-F238E27FC236}">
-                <a16:creationId xmlns:a16="http://schemas.microsoft.com/office/drawing/2014/main" id="{85765D79-5D4B-484F-9409-AC6CE2550D2B}"/>
+                <a16:creationId xmlns:a16="http://schemas.microsoft.com/office/drawing/2014/main" id="{633BDCA4-BE89-41F3-80CF-D066A4380054}"/>
               </a:ext>
             </a:extLst>
           </p:cNvPr>
@@ -7890,7 +7890,7 @@
           <p:cNvPr id="7" name="">
             <a:extLst xmlns:a="http://schemas.openxmlformats.org/drawingml/2006/main">
               <a:ext uri="{FF2B5EF4-FFF2-40B4-BE49-F238E27FC236}">
-                <a16:creationId xmlns:a16="http://schemas.microsoft.com/office/drawing/2014/main" id="{5660EE0B-8DA4-4134-B786-64C4E420EBA8}"/>
+                <a16:creationId xmlns:a16="http://schemas.microsoft.com/office/drawing/2014/main" id="{1455F01C-93B8-4AB6-A9C9-D96B59AC2245}"/>
               </a:ext>
             </a:extLst>
           </p:cNvPr>
@@ -7947,7 +7947,7 @@
           <p:cNvPr id="8" name="">
             <a:extLst xmlns:a="http://schemas.openxmlformats.org/drawingml/2006/main">
               <a:ext uri="{FF2B5EF4-FFF2-40B4-BE49-F238E27FC236}">
-                <a16:creationId xmlns:a16="http://schemas.microsoft.com/office/drawing/2014/main" id="{528BD176-05F7-4A14-BF05-8FA3D11CB489}"/>
+                <a16:creationId xmlns:a16="http://schemas.microsoft.com/office/drawing/2014/main" id="{51C9ED1A-9615-43E5-A345-51495E8D19A7}"/>
               </a:ext>
             </a:extLst>
           </p:cNvPr>
@@ -7982,7 +7982,7 @@
           <p:cNvPr id="9" name="">
             <a:extLst xmlns:a="http://schemas.openxmlformats.org/drawingml/2006/main">
               <a:ext uri="{FF2B5EF4-FFF2-40B4-BE49-F238E27FC236}">
-                <a16:creationId xmlns:a16="http://schemas.microsoft.com/office/drawing/2014/main" id="{539A7834-67DB-4229-86CF-513C2A1686B7}"/>
+                <a16:creationId xmlns:a16="http://schemas.microsoft.com/office/drawing/2014/main" id="{B7D16CA9-E713-4658-8741-089A6B0C08C9}"/>
               </a:ext>
             </a:extLst>
           </p:cNvPr>
@@ -8039,7 +8039,7 @@
           <p:cNvPr id="10" name="">
             <a:extLst xmlns:a="http://schemas.openxmlformats.org/drawingml/2006/main">
               <a:ext uri="{FF2B5EF4-FFF2-40B4-BE49-F238E27FC236}">
-                <a16:creationId xmlns:a16="http://schemas.microsoft.com/office/drawing/2014/main" id="{C7657ABE-0F70-46CC-B670-8608DF93899C}"/>
+                <a16:creationId xmlns:a16="http://schemas.microsoft.com/office/drawing/2014/main" id="{FE599488-F08A-4A82-8216-9FA354AC1E5F}"/>
               </a:ext>
             </a:extLst>
           </p:cNvPr>
@@ -8096,7 +8096,7 @@
           <p:cNvPr id="11" name="">
             <a:extLst xmlns:a="http://schemas.openxmlformats.org/drawingml/2006/main">
               <a:ext uri="{FF2B5EF4-FFF2-40B4-BE49-F238E27FC236}">
-                <a16:creationId xmlns:a16="http://schemas.microsoft.com/office/drawing/2014/main" id="{513D232A-6288-4B20-8697-B19456630BCE}"/>
+                <a16:creationId xmlns:a16="http://schemas.microsoft.com/office/drawing/2014/main" id="{D19EEF78-76C4-4C15-BCE6-95D19554CF5A}"/>
               </a:ext>
             </a:extLst>
           </p:cNvPr>
@@ -8153,7 +8153,7 @@
           <p:cNvPr id="12" name="">
             <a:extLst xmlns:a="http://schemas.openxmlformats.org/drawingml/2006/main">
               <a:ext uri="{FF2B5EF4-FFF2-40B4-BE49-F238E27FC236}">
-                <a16:creationId xmlns:a16="http://schemas.microsoft.com/office/drawing/2014/main" id="{5AC0AC41-0D81-4393-A738-CB62A5BD1FE3}"/>
+                <a16:creationId xmlns:a16="http://schemas.microsoft.com/office/drawing/2014/main" id="{1DFA1D94-87A6-4848-B863-2A0FF20DE868}"/>
               </a:ext>
             </a:extLst>
           </p:cNvPr>
@@ -8188,7 +8188,7 @@
           <p:cNvPr id="13" name="">
             <a:extLst xmlns:a="http://schemas.openxmlformats.org/drawingml/2006/main">
               <a:ext uri="{FF2B5EF4-FFF2-40B4-BE49-F238E27FC236}">
-                <a16:creationId xmlns:a16="http://schemas.microsoft.com/office/drawing/2014/main" id="{BBD7F074-12EE-438C-9CAB-B4EE38F0BD65}"/>
+                <a16:creationId xmlns:a16="http://schemas.microsoft.com/office/drawing/2014/main" id="{8DD8B2B9-5EDE-4CD9-963A-6F520FA31193}"/>
               </a:ext>
             </a:extLst>
           </p:cNvPr>
@@ -8245,7 +8245,7 @@
           <p:cNvPr id="14" name="">
             <a:extLst xmlns:a="http://schemas.openxmlformats.org/drawingml/2006/main">
               <a:ext uri="{FF2B5EF4-FFF2-40B4-BE49-F238E27FC236}">
-                <a16:creationId xmlns:a16="http://schemas.microsoft.com/office/drawing/2014/main" id="{D8F0E2A3-2BE5-428A-9EBD-CD845EA27782}"/>
+                <a16:creationId xmlns:a16="http://schemas.microsoft.com/office/drawing/2014/main" id="{A39DF91A-EDA9-4F01-BFCB-202A0E4BFEB1}"/>
               </a:ext>
             </a:extLst>
           </p:cNvPr>
@@ -8302,7 +8302,7 @@
           <p:cNvPr id="15" name="">
             <a:extLst xmlns:a="http://schemas.openxmlformats.org/drawingml/2006/main">
               <a:ext uri="{FF2B5EF4-FFF2-40B4-BE49-F238E27FC236}">
-                <a16:creationId xmlns:a16="http://schemas.microsoft.com/office/drawing/2014/main" id="{BA37F757-99D3-474B-B992-09451B32D4EE}"/>
+                <a16:creationId xmlns:a16="http://schemas.microsoft.com/office/drawing/2014/main" id="{48474CBF-1F80-4BFC-855F-A9ADF4DA8A97}"/>
               </a:ext>
             </a:extLst>
           </p:cNvPr>
@@ -8359,7 +8359,7 @@
           <p:cNvPr id="16" name="">
             <a:extLst xmlns:a="http://schemas.openxmlformats.org/drawingml/2006/main">
               <a:ext uri="{FF2B5EF4-FFF2-40B4-BE49-F238E27FC236}">
-                <a16:creationId xmlns:a16="http://schemas.microsoft.com/office/drawing/2014/main" id="{D38D2228-4043-49AD-8E2C-7E3AEAD1DDE0}"/>
+                <a16:creationId xmlns:a16="http://schemas.microsoft.com/office/drawing/2014/main" id="{8FA2577C-CD37-41C8-8461-C277FD21A265}"/>
               </a:ext>
             </a:extLst>
           </p:cNvPr>
@@ -8394,7 +8394,7 @@
           <p:cNvPr id="17" name="">
             <a:extLst xmlns:a="http://schemas.openxmlformats.org/drawingml/2006/main">
               <a:ext uri="{FF2B5EF4-FFF2-40B4-BE49-F238E27FC236}">
-                <a16:creationId xmlns:a16="http://schemas.microsoft.com/office/drawing/2014/main" id="{F6B7D8C2-29FE-42A1-B730-E3E025C60693}"/>
+                <a16:creationId xmlns:a16="http://schemas.microsoft.com/office/drawing/2014/main" id="{A8E8BBA1-3627-4BA9-A004-D5843649B342}"/>
               </a:ext>
             </a:extLst>
           </p:cNvPr>
@@ -8451,7 +8451,7 @@
           <p:cNvPr id="18" name="">
             <a:extLst xmlns:a="http://schemas.openxmlformats.org/drawingml/2006/main">
               <a:ext uri="{FF2B5EF4-FFF2-40B4-BE49-F238E27FC236}">
-                <a16:creationId xmlns:a16="http://schemas.microsoft.com/office/drawing/2014/main" id="{35B57202-0666-4EAB-99A6-E0FB11A67CA3}"/>
+                <a16:creationId xmlns:a16="http://schemas.microsoft.com/office/drawing/2014/main" id="{9A3F2598-BE96-4F57-87A4-5E830F938B61}"/>
               </a:ext>
             </a:extLst>
           </p:cNvPr>
@@ -8508,7 +8508,7 @@
           <p:cNvPr id="19" name="">
             <a:extLst xmlns:a="http://schemas.openxmlformats.org/drawingml/2006/main">
               <a:ext uri="{FF2B5EF4-FFF2-40B4-BE49-F238E27FC236}">
-                <a16:creationId xmlns:a16="http://schemas.microsoft.com/office/drawing/2014/main" id="{09305293-C3A8-425E-8960-DCF24871F9D2}"/>
+                <a16:creationId xmlns:a16="http://schemas.microsoft.com/office/drawing/2014/main" id="{8E4CE1C8-949D-47DC-88E8-32ED6A80AD41}"/>
               </a:ext>
             </a:extLst>
           </p:cNvPr>
@@ -8565,7 +8565,7 @@
           <p:cNvPr id="20" name="">
             <a:extLst xmlns:a="http://schemas.openxmlformats.org/drawingml/2006/main">
               <a:ext uri="{FF2B5EF4-FFF2-40B4-BE49-F238E27FC236}">
-                <a16:creationId xmlns:a16="http://schemas.microsoft.com/office/drawing/2014/main" id="{CC375ADE-88C1-45FD-AD14-86A94976EE18}"/>
+                <a16:creationId xmlns:a16="http://schemas.microsoft.com/office/drawing/2014/main" id="{5424E16D-1BC0-4248-8C29-EDE41AE64405}"/>
               </a:ext>
             </a:extLst>
           </p:cNvPr>
@@ -8622,7 +8622,7 @@
           <p:cNvPr id="21" name="">
             <a:extLst xmlns:a="http://schemas.openxmlformats.org/drawingml/2006/main">
               <a:ext uri="{FF2B5EF4-FFF2-40B4-BE49-F238E27FC236}">
-                <a16:creationId xmlns:a16="http://schemas.microsoft.com/office/drawing/2014/main" id="{F8727F61-9472-42A9-B028-50A742FE230F}"/>
+                <a16:creationId xmlns:a16="http://schemas.microsoft.com/office/drawing/2014/main" id="{6C31C018-19B3-47C9-A7D2-1AF722D00045}"/>
               </a:ext>
             </a:extLst>
           </p:cNvPr>
@@ -8679,7 +8679,7 @@
           <p:cNvPr id="22" name="">
             <a:extLst xmlns:a="http://schemas.openxmlformats.org/drawingml/2006/main">
               <a:ext uri="{FF2B5EF4-FFF2-40B4-BE49-F238E27FC236}">
-                <a16:creationId xmlns:a16="http://schemas.microsoft.com/office/drawing/2014/main" id="{A033D92F-5E5C-47EA-A39C-F08494B8EFCE}"/>
+                <a16:creationId xmlns:a16="http://schemas.microsoft.com/office/drawing/2014/main" id="{0EAF4C19-2070-43B7-A4E9-7BF59DBDBA28}"/>
               </a:ext>
             </a:extLst>
           </p:cNvPr>
@@ -8734,7 +8734,7 @@
     </p:spTree>
     <p:extLst>
       <p:ext uri="{BB962C8B-B14F-4D97-AF65-F5344CB8AC3E}">
-        <p14:creationId xmlns:p14="http://schemas.microsoft.com/office/powerpoint/2010/main" val="1407328687"/>
+        <p14:creationId xmlns:p14="http://schemas.microsoft.com/office/powerpoint/2010/main" val="2123463553"/>
       </p:ext>
     </p:extLst>
   </p:cSld>
@@ -8765,7 +8765,7 @@
           <p:cNvPr id="23" name="">
             <a:extLst xmlns:a="http://schemas.openxmlformats.org/drawingml/2006/main">
               <a:ext uri="{FF2B5EF4-FFF2-40B4-BE49-F238E27FC236}">
-                <a16:creationId xmlns:a16="http://schemas.microsoft.com/office/drawing/2014/main" id="{78553C41-B989-4E0A-87A4-FC36FD9DE218}"/>
+                <a16:creationId xmlns:a16="http://schemas.microsoft.com/office/drawing/2014/main" id="{92012CF3-E584-49B2-8004-03BB85C4D381}"/>
               </a:ext>
             </a:extLst>
           </p:cNvPr>
@@ -8822,7 +8822,7 @@
           <p:cNvPr id="2" name="">
             <a:extLst xmlns:a="http://schemas.openxmlformats.org/drawingml/2006/main">
               <a:ext uri="{FF2B5EF4-FFF2-40B4-BE49-F238E27FC236}">
-                <a16:creationId xmlns:a16="http://schemas.microsoft.com/office/drawing/2014/main" id="{7E4D6184-49EE-4FA1-88D1-DABBC03B9E6B}"/>
+                <a16:creationId xmlns:a16="http://schemas.microsoft.com/office/drawing/2014/main" id="{656F6A93-29F8-4A86-868F-11BF419B128B}"/>
               </a:ext>
             </a:extLst>
           </p:cNvPr>
@@ -8883,7 +8883,7 @@
           <p:nvPr/>
         </p:nvPicPr>
         <p:blipFill>
-          <a:blip xmlns:r="http://schemas.openxmlformats.org/officeDocument/2006/relationships" xmlns:a="http://schemas.openxmlformats.org/drawingml/2006/main" r:embed="Refe5264a13214a77"/>
+          <a:blip xmlns:r="http://schemas.openxmlformats.org/officeDocument/2006/relationships" xmlns:a="http://schemas.openxmlformats.org/drawingml/2006/main" r:embed="R15608d6636354517"/>
           <a:stretch xmlns:a="http://schemas.openxmlformats.org/drawingml/2006/main"/>
         </p:blipFill>
         <p:spPr>
@@ -8901,7 +8901,7 @@
           <p:cNvPr id="4" name="">
             <a:extLst xmlns:a="http://schemas.openxmlformats.org/drawingml/2006/main">
               <a:ext uri="{FF2B5EF4-FFF2-40B4-BE49-F238E27FC236}">
-                <a16:creationId xmlns:a16="http://schemas.microsoft.com/office/drawing/2014/main" id="{ED30BCE6-A1E9-43E5-A491-EE41B493A53B}"/>
+                <a16:creationId xmlns:a16="http://schemas.microsoft.com/office/drawing/2014/main" id="{D75A301E-36A8-4D0F-816C-DEC10DB37CE1}"/>
               </a:ext>
             </a:extLst>
           </p:cNvPr>
@@ -8958,7 +8958,7 @@
           <p:cNvPr id="5" name="">
             <a:extLst xmlns:a="http://schemas.openxmlformats.org/drawingml/2006/main">
               <a:ext uri="{FF2B5EF4-FFF2-40B4-BE49-F238E27FC236}">
-                <a16:creationId xmlns:a16="http://schemas.microsoft.com/office/drawing/2014/main" id="{CA679438-AE96-4633-BECC-3168328D2847}"/>
+                <a16:creationId xmlns:a16="http://schemas.microsoft.com/office/drawing/2014/main" id="{97E17E47-69D7-4E20-BC02-92E1F9FF0EA2}"/>
               </a:ext>
             </a:extLst>
           </p:cNvPr>
@@ -8993,7 +8993,7 @@
           <p:cNvPr id="6" name="">
             <a:extLst xmlns:a="http://schemas.openxmlformats.org/drawingml/2006/main">
               <a:ext uri="{FF2B5EF4-FFF2-40B4-BE49-F238E27FC236}">
-                <a16:creationId xmlns:a16="http://schemas.microsoft.com/office/drawing/2014/main" id="{29C8AD4D-83E1-416C-AA82-626D488B8364}"/>
+                <a16:creationId xmlns:a16="http://schemas.microsoft.com/office/drawing/2014/main" id="{AAEF4FDF-A317-4B5F-B808-EAFBDC64FF3B}"/>
               </a:ext>
             </a:extLst>
           </p:cNvPr>
@@ -9023,7 +9023,7 @@
           <p:cNvPr id="7" name="">
             <a:extLst xmlns:a="http://schemas.openxmlformats.org/drawingml/2006/main">
               <a:ext uri="{FF2B5EF4-FFF2-40B4-BE49-F238E27FC236}">
-                <a16:creationId xmlns:a16="http://schemas.microsoft.com/office/drawing/2014/main" id="{4ADBE596-8D8C-4ED8-AA87-BF694FC2D575}"/>
+                <a16:creationId xmlns:a16="http://schemas.microsoft.com/office/drawing/2014/main" id="{9F0E17F9-A023-490D-9566-311952E793D5}"/>
               </a:ext>
             </a:extLst>
           </p:cNvPr>
@@ -9080,7 +9080,7 @@
           <p:cNvPr id="8" name="">
             <a:extLst xmlns:a="http://schemas.openxmlformats.org/drawingml/2006/main">
               <a:ext uri="{FF2B5EF4-FFF2-40B4-BE49-F238E27FC236}">
-                <a16:creationId xmlns:a16="http://schemas.microsoft.com/office/drawing/2014/main" id="{ACA20ACA-B308-4717-BDA1-C76CDD3B6826}"/>
+                <a16:creationId xmlns:a16="http://schemas.microsoft.com/office/drawing/2014/main" id="{75ACBA47-029D-4209-AEBF-43FEE2D00AF6}"/>
               </a:ext>
             </a:extLst>
           </p:cNvPr>
@@ -9137,7 +9137,7 @@
           <p:cNvPr id="9" name="">
             <a:extLst xmlns:a="http://schemas.openxmlformats.org/drawingml/2006/main">
               <a:ext uri="{FF2B5EF4-FFF2-40B4-BE49-F238E27FC236}">
-                <a16:creationId xmlns:a16="http://schemas.microsoft.com/office/drawing/2014/main" id="{3906FEAE-0522-4228-905E-C55A8BA483EA}"/>
+                <a16:creationId xmlns:a16="http://schemas.microsoft.com/office/drawing/2014/main" id="{D06339FB-FDCD-441B-B2D4-D356B9C524C9}"/>
               </a:ext>
             </a:extLst>
           </p:cNvPr>
@@ -9172,7 +9172,7 @@
           <p:cNvPr id="10" name="">
             <a:extLst xmlns:a="http://schemas.openxmlformats.org/drawingml/2006/main">
               <a:ext uri="{FF2B5EF4-FFF2-40B4-BE49-F238E27FC236}">
-                <a16:creationId xmlns:a16="http://schemas.microsoft.com/office/drawing/2014/main" id="{458AFC1F-73C2-4A31-8561-8502F9FB31C0}"/>
+                <a16:creationId xmlns:a16="http://schemas.microsoft.com/office/drawing/2014/main" id="{5A517403-4802-4C02-9A5F-0E2EE8852FA3}"/>
               </a:ext>
             </a:extLst>
           </p:cNvPr>
@@ -9202,7 +9202,7 @@
           <p:cNvPr id="11" name="">
             <a:extLst xmlns:a="http://schemas.openxmlformats.org/drawingml/2006/main">
               <a:ext uri="{FF2B5EF4-FFF2-40B4-BE49-F238E27FC236}">
-                <a16:creationId xmlns:a16="http://schemas.microsoft.com/office/drawing/2014/main" id="{9D7D208D-B798-46A2-9A88-C3DB978A4356}"/>
+                <a16:creationId xmlns:a16="http://schemas.microsoft.com/office/drawing/2014/main" id="{B6BDA277-D966-4E16-8490-DD0B966B173C}"/>
               </a:ext>
             </a:extLst>
           </p:cNvPr>
@@ -9259,7 +9259,7 @@
           <p:cNvPr id="12" name="">
             <a:extLst xmlns:a="http://schemas.openxmlformats.org/drawingml/2006/main">
               <a:ext uri="{FF2B5EF4-FFF2-40B4-BE49-F238E27FC236}">
-                <a16:creationId xmlns:a16="http://schemas.microsoft.com/office/drawing/2014/main" id="{587E11C2-C2F5-4D02-9CBB-9A73C7A2D3DD}"/>
+                <a16:creationId xmlns:a16="http://schemas.microsoft.com/office/drawing/2014/main" id="{2FDECF23-BF7A-47AE-BA5B-362F1CEA88EA}"/>
               </a:ext>
             </a:extLst>
           </p:cNvPr>
@@ -9316,7 +9316,7 @@
           <p:cNvPr id="13" name="">
             <a:extLst xmlns:a="http://schemas.openxmlformats.org/drawingml/2006/main">
               <a:ext uri="{FF2B5EF4-FFF2-40B4-BE49-F238E27FC236}">
-                <a16:creationId xmlns:a16="http://schemas.microsoft.com/office/drawing/2014/main" id="{377BCA88-2C9E-4B3B-94A2-3FB6C3BDD717}"/>
+                <a16:creationId xmlns:a16="http://schemas.microsoft.com/office/drawing/2014/main" id="{2032ABC9-1309-4D72-8203-00C8169CE841}"/>
               </a:ext>
             </a:extLst>
           </p:cNvPr>
@@ -9351,7 +9351,7 @@
           <p:cNvPr id="14" name="">
             <a:extLst xmlns:a="http://schemas.openxmlformats.org/drawingml/2006/main">
               <a:ext uri="{FF2B5EF4-FFF2-40B4-BE49-F238E27FC236}">
-                <a16:creationId xmlns:a16="http://schemas.microsoft.com/office/drawing/2014/main" id="{A38C97A8-A7B5-4FE3-9278-7958DE3B4D84}"/>
+                <a16:creationId xmlns:a16="http://schemas.microsoft.com/office/drawing/2014/main" id="{42276F75-310B-4960-95DE-40C1C342889C}"/>
               </a:ext>
             </a:extLst>
           </p:cNvPr>
@@ -9381,7 +9381,7 @@
           <p:cNvPr id="15" name="">
             <a:extLst xmlns:a="http://schemas.openxmlformats.org/drawingml/2006/main">
               <a:ext uri="{FF2B5EF4-FFF2-40B4-BE49-F238E27FC236}">
-                <a16:creationId xmlns:a16="http://schemas.microsoft.com/office/drawing/2014/main" id="{AB535725-76FC-4518-91AE-E49ECC5298AE}"/>
+                <a16:creationId xmlns:a16="http://schemas.microsoft.com/office/drawing/2014/main" id="{0BD26DEF-F9A6-41DA-A859-0115F75B7644}"/>
               </a:ext>
             </a:extLst>
           </p:cNvPr>
@@ -9438,7 +9438,7 @@
           <p:cNvPr id="16" name="">
             <a:extLst xmlns:a="http://schemas.openxmlformats.org/drawingml/2006/main">
               <a:ext uri="{FF2B5EF4-FFF2-40B4-BE49-F238E27FC236}">
-                <a16:creationId xmlns:a16="http://schemas.microsoft.com/office/drawing/2014/main" id="{973BE2E4-665E-4AF1-9D7E-7FCF75D4706D}"/>
+                <a16:creationId xmlns:a16="http://schemas.microsoft.com/office/drawing/2014/main" id="{6189C29F-D07C-4D0B-89CC-479FB13F8B8B}"/>
               </a:ext>
             </a:extLst>
           </p:cNvPr>
@@ -9495,7 +9495,7 @@
           <p:cNvPr id="17" name="">
             <a:extLst xmlns:a="http://schemas.openxmlformats.org/drawingml/2006/main">
               <a:ext uri="{FF2B5EF4-FFF2-40B4-BE49-F238E27FC236}">
-                <a16:creationId xmlns:a16="http://schemas.microsoft.com/office/drawing/2014/main" id="{24A3EF84-8A00-422F-835D-32F7CC93225B}"/>
+                <a16:creationId xmlns:a16="http://schemas.microsoft.com/office/drawing/2014/main" id="{47C3CBF5-84E5-4E45-A9DE-C2E88C85FEF4}"/>
               </a:ext>
             </a:extLst>
           </p:cNvPr>
@@ -9530,7 +9530,7 @@
           <p:cNvPr id="18" name="">
             <a:extLst xmlns:a="http://schemas.openxmlformats.org/drawingml/2006/main">
               <a:ext uri="{FF2B5EF4-FFF2-40B4-BE49-F238E27FC236}">
-                <a16:creationId xmlns:a16="http://schemas.microsoft.com/office/drawing/2014/main" id="{4B54FFE5-2878-499F-B298-71FB1962AA8F}"/>
+                <a16:creationId xmlns:a16="http://schemas.microsoft.com/office/drawing/2014/main" id="{3FDEC2A5-23AD-427E-A0FA-73C872BBA20B}"/>
               </a:ext>
             </a:extLst>
           </p:cNvPr>
@@ -9560,7 +9560,7 @@
           <p:cNvPr id="19" name="">
             <a:extLst xmlns:a="http://schemas.openxmlformats.org/drawingml/2006/main">
               <a:ext uri="{FF2B5EF4-FFF2-40B4-BE49-F238E27FC236}">
-                <a16:creationId xmlns:a16="http://schemas.microsoft.com/office/drawing/2014/main" id="{3009AD61-88C3-4272-AF81-83169A3E69D8}"/>
+                <a16:creationId xmlns:a16="http://schemas.microsoft.com/office/drawing/2014/main" id="{A23FE9B6-2D4C-4D0D-98AA-1EFFBCB691DE}"/>
               </a:ext>
             </a:extLst>
           </p:cNvPr>
@@ -9617,7 +9617,7 @@
           <p:cNvPr id="20" name="">
             <a:extLst xmlns:a="http://schemas.openxmlformats.org/drawingml/2006/main">
               <a:ext uri="{FF2B5EF4-FFF2-40B4-BE49-F238E27FC236}">
-                <a16:creationId xmlns:a16="http://schemas.microsoft.com/office/drawing/2014/main" id="{5F1F9C85-834C-4752-B5F5-AF647F1FB91A}"/>
+                <a16:creationId xmlns:a16="http://schemas.microsoft.com/office/drawing/2014/main" id="{36937A3E-F85C-4EBE-B702-C1BB3CCBA486}"/>
               </a:ext>
             </a:extLst>
           </p:cNvPr>
@@ -9674,7 +9674,7 @@
           <p:cNvPr id="21" name="">
             <a:extLst xmlns:a="http://schemas.openxmlformats.org/drawingml/2006/main">
               <a:ext uri="{FF2B5EF4-FFF2-40B4-BE49-F238E27FC236}">
-                <a16:creationId xmlns:a16="http://schemas.microsoft.com/office/drawing/2014/main" id="{0B11E1F3-7531-4F04-BEFB-9E129B68E619}"/>
+                <a16:creationId xmlns:a16="http://schemas.microsoft.com/office/drawing/2014/main" id="{E363430E-EBA7-4BA9-90F0-C92036748B5B}"/>
               </a:ext>
             </a:extLst>
           </p:cNvPr>
@@ -9731,7 +9731,7 @@
           <p:cNvPr id="22" name="">
             <a:extLst xmlns:a="http://schemas.openxmlformats.org/drawingml/2006/main">
               <a:ext uri="{FF2B5EF4-FFF2-40B4-BE49-F238E27FC236}">
-                <a16:creationId xmlns:a16="http://schemas.microsoft.com/office/drawing/2014/main" id="{D95DD231-F4B8-481A-8A03-961B0ADFE24B}"/>
+                <a16:creationId xmlns:a16="http://schemas.microsoft.com/office/drawing/2014/main" id="{C4E59E98-3F3F-4795-A262-B8E267081F16}"/>
               </a:ext>
             </a:extLst>
           </p:cNvPr>
@@ -9786,7 +9786,7 @@
     </p:spTree>
     <p:extLst>
       <p:ext uri="{BB962C8B-B14F-4D97-AF65-F5344CB8AC3E}">
-        <p14:creationId xmlns:p14="http://schemas.microsoft.com/office/powerpoint/2010/main" val="53600167"/>
+        <p14:creationId xmlns:p14="http://schemas.microsoft.com/office/powerpoint/2010/main" val="1372639778"/>
       </p:ext>
     </p:extLst>
   </p:cSld>
@@ -9817,7 +9817,7 @@
           <p:cNvPr id="17" name="">
             <a:extLst xmlns:a="http://schemas.openxmlformats.org/drawingml/2006/main">
               <a:ext uri="{FF2B5EF4-FFF2-40B4-BE49-F238E27FC236}">
-                <a16:creationId xmlns:a16="http://schemas.microsoft.com/office/drawing/2014/main" id="{BE35C8A6-30EF-41C6-A6C7-1B8C5F8BC01E}"/>
+                <a16:creationId xmlns:a16="http://schemas.microsoft.com/office/drawing/2014/main" id="{C8EC1F27-B770-446E-BD0E-4FF1B79C935D}"/>
               </a:ext>
             </a:extLst>
           </p:cNvPr>
@@ -9874,7 +9874,7 @@
           <p:cNvPr id="2" name="">
             <a:extLst xmlns:a="http://schemas.openxmlformats.org/drawingml/2006/main">
               <a:ext uri="{FF2B5EF4-FFF2-40B4-BE49-F238E27FC236}">
-                <a16:creationId xmlns:a16="http://schemas.microsoft.com/office/drawing/2014/main" id="{FA569388-6DF2-46CF-B9AC-96FC2618F5EF}"/>
+                <a16:creationId xmlns:a16="http://schemas.microsoft.com/office/drawing/2014/main" id="{F8A14D14-819D-4C0B-9923-85B4D98B07AE}"/>
               </a:ext>
             </a:extLst>
           </p:cNvPr>
@@ -9935,7 +9935,7 @@
           <p:nvPr/>
         </p:nvPicPr>
         <p:blipFill>
-          <a:blip xmlns:r="http://schemas.openxmlformats.org/officeDocument/2006/relationships" xmlns:a="http://schemas.openxmlformats.org/drawingml/2006/main" r:embed="Rb312d710f56848af"/>
+          <a:blip xmlns:r="http://schemas.openxmlformats.org/officeDocument/2006/relationships" xmlns:a="http://schemas.openxmlformats.org/drawingml/2006/main" r:embed="R8ff3351364dd4206"/>
           <a:stretch xmlns:a="http://schemas.openxmlformats.org/drawingml/2006/main"/>
         </p:blipFill>
         <p:spPr>
@@ -9953,7 +9953,7 @@
           <p:cNvPr id="4" name="">
             <a:extLst xmlns:a="http://schemas.openxmlformats.org/drawingml/2006/main">
               <a:ext uri="{FF2B5EF4-FFF2-40B4-BE49-F238E27FC236}">
-                <a16:creationId xmlns:a16="http://schemas.microsoft.com/office/drawing/2014/main" id="{ED61E423-6636-4478-B713-45EB352698C2}"/>
+                <a16:creationId xmlns:a16="http://schemas.microsoft.com/office/drawing/2014/main" id="{B45E398B-B211-4FD7-BB3F-E10A820F50D6}"/>
               </a:ext>
             </a:extLst>
           </p:cNvPr>
@@ -10010,7 +10010,7 @@
           <p:cNvPr id="5" name="">
             <a:extLst xmlns:a="http://schemas.openxmlformats.org/drawingml/2006/main">
               <a:ext uri="{FF2B5EF4-FFF2-40B4-BE49-F238E27FC236}">
-                <a16:creationId xmlns:a16="http://schemas.microsoft.com/office/drawing/2014/main" id="{71F03E2D-71DB-4F93-9344-48EBBBD40D3B}"/>
+                <a16:creationId xmlns:a16="http://schemas.microsoft.com/office/drawing/2014/main" id="{5B0B27B7-B8AF-4EC9-A702-F2AF7C805328}"/>
               </a:ext>
             </a:extLst>
           </p:cNvPr>
@@ -10040,7 +10040,7 @@
           <p:cNvPr id="6" name="">
             <a:extLst xmlns:a="http://schemas.openxmlformats.org/drawingml/2006/main">
               <a:ext uri="{FF2B5EF4-FFF2-40B4-BE49-F238E27FC236}">
-                <a16:creationId xmlns:a16="http://schemas.microsoft.com/office/drawing/2014/main" id="{B057271E-42D4-4062-98E8-CCD219CF7128}"/>
+                <a16:creationId xmlns:a16="http://schemas.microsoft.com/office/drawing/2014/main" id="{756B4D23-2569-494B-ABA8-8AB5FB690B30}"/>
               </a:ext>
             </a:extLst>
           </p:cNvPr>
@@ -10097,7 +10097,7 @@
           <p:cNvPr id="7" name="">
             <a:extLst xmlns:a="http://schemas.openxmlformats.org/drawingml/2006/main">
               <a:ext uri="{FF2B5EF4-FFF2-40B4-BE49-F238E27FC236}">
-                <a16:creationId xmlns:a16="http://schemas.microsoft.com/office/drawing/2014/main" id="{DCD8C974-35AA-4CD1-977A-C8566A8BA7F6}"/>
+                <a16:creationId xmlns:a16="http://schemas.microsoft.com/office/drawing/2014/main" id="{8EB06A29-62C3-4050-9686-76C1C8436E56}"/>
               </a:ext>
             </a:extLst>
           </p:cNvPr>
@@ -10127,7 +10127,7 @@
           <p:cNvPr id="8" name="">
             <a:extLst xmlns:a="http://schemas.openxmlformats.org/drawingml/2006/main">
               <a:ext uri="{FF2B5EF4-FFF2-40B4-BE49-F238E27FC236}">
-                <a16:creationId xmlns:a16="http://schemas.microsoft.com/office/drawing/2014/main" id="{23CAD957-3A10-4955-AD27-1A7F7D62A2DD}"/>
+                <a16:creationId xmlns:a16="http://schemas.microsoft.com/office/drawing/2014/main" id="{73B8E179-8B33-49F5-B00A-3E7A1D408042}"/>
               </a:ext>
             </a:extLst>
           </p:cNvPr>
@@ -10184,7 +10184,7 @@
           <p:cNvPr id="9" name="">
             <a:extLst xmlns:a="http://schemas.openxmlformats.org/drawingml/2006/main">
               <a:ext uri="{FF2B5EF4-FFF2-40B4-BE49-F238E27FC236}">
-                <a16:creationId xmlns:a16="http://schemas.microsoft.com/office/drawing/2014/main" id="{EC0FAE60-0373-4A7D-85FC-CBDCF04231BF}"/>
+                <a16:creationId xmlns:a16="http://schemas.microsoft.com/office/drawing/2014/main" id="{DCC312CE-A902-4397-8BC3-D2C12D412C45}"/>
               </a:ext>
             </a:extLst>
           </p:cNvPr>
@@ -10214,7 +10214,7 @@
           <p:cNvPr id="10" name="">
             <a:extLst xmlns:a="http://schemas.openxmlformats.org/drawingml/2006/main">
               <a:ext uri="{FF2B5EF4-FFF2-40B4-BE49-F238E27FC236}">
-                <a16:creationId xmlns:a16="http://schemas.microsoft.com/office/drawing/2014/main" id="{825E9E2D-F8E5-4874-85E1-BA37BA1BC47A}"/>
+                <a16:creationId xmlns:a16="http://schemas.microsoft.com/office/drawing/2014/main" id="{F0CF4031-B374-4CEA-915A-0EA6202441D5}"/>
               </a:ext>
             </a:extLst>
           </p:cNvPr>
@@ -10271,7 +10271,7 @@
           <p:cNvPr id="11" name="">
             <a:extLst xmlns:a="http://schemas.openxmlformats.org/drawingml/2006/main">
               <a:ext uri="{FF2B5EF4-FFF2-40B4-BE49-F238E27FC236}">
-                <a16:creationId xmlns:a16="http://schemas.microsoft.com/office/drawing/2014/main" id="{C048EFF4-F81E-4BAE-BA45-4157D48DE051}"/>
+                <a16:creationId xmlns:a16="http://schemas.microsoft.com/office/drawing/2014/main" id="{1B18466E-C1AF-498E-857B-E227F3F5A3F0}"/>
               </a:ext>
             </a:extLst>
           </p:cNvPr>
@@ -10301,7 +10301,7 @@
           <p:cNvPr id="12" name="">
             <a:extLst xmlns:a="http://schemas.openxmlformats.org/drawingml/2006/main">
               <a:ext uri="{FF2B5EF4-FFF2-40B4-BE49-F238E27FC236}">
-                <a16:creationId xmlns:a16="http://schemas.microsoft.com/office/drawing/2014/main" id="{0BD65C68-455C-414A-A55A-CE1A61059855}"/>
+                <a16:creationId xmlns:a16="http://schemas.microsoft.com/office/drawing/2014/main" id="{39A9B473-DDDB-4C8F-B23C-9B5068751B39}"/>
               </a:ext>
             </a:extLst>
           </p:cNvPr>
@@ -10358,7 +10358,7 @@
           <p:cNvPr id="13" name="">
             <a:extLst xmlns:a="http://schemas.openxmlformats.org/drawingml/2006/main">
               <a:ext uri="{FF2B5EF4-FFF2-40B4-BE49-F238E27FC236}">
-                <a16:creationId xmlns:a16="http://schemas.microsoft.com/office/drawing/2014/main" id="{5668505E-F8EB-455C-82B7-BE87220E2B92}"/>
+                <a16:creationId xmlns:a16="http://schemas.microsoft.com/office/drawing/2014/main" id="{8B31E2E7-AB01-4923-8326-4A93D82C1DA1}"/>
               </a:ext>
             </a:extLst>
           </p:cNvPr>
@@ -10393,7 +10393,7 @@
           <p:cNvPr id="14" name="">
             <a:extLst xmlns:a="http://schemas.openxmlformats.org/drawingml/2006/main">
               <a:ext uri="{FF2B5EF4-FFF2-40B4-BE49-F238E27FC236}">
-                <a16:creationId xmlns:a16="http://schemas.microsoft.com/office/drawing/2014/main" id="{BC30D00B-8217-4950-9A50-AF5FEEE8E4A2}"/>
+                <a16:creationId xmlns:a16="http://schemas.microsoft.com/office/drawing/2014/main" id="{1A940A88-49A4-4476-897F-EFB432A1316C}"/>
               </a:ext>
             </a:extLst>
           </p:cNvPr>
@@ -10450,7 +10450,7 @@
           <p:cNvPr id="15" name="">
             <a:extLst xmlns:a="http://schemas.openxmlformats.org/drawingml/2006/main">
               <a:ext uri="{FF2B5EF4-FFF2-40B4-BE49-F238E27FC236}">
-                <a16:creationId xmlns:a16="http://schemas.microsoft.com/office/drawing/2014/main" id="{C4B31D4D-601A-4C86-BD49-7DF8AAFB3F25}"/>
+                <a16:creationId xmlns:a16="http://schemas.microsoft.com/office/drawing/2014/main" id="{F0AC4310-94C1-48C7-9F67-69348EBB8EE9}"/>
               </a:ext>
             </a:extLst>
           </p:cNvPr>
@@ -10507,7 +10507,7 @@
           <p:cNvPr id="16" name="">
             <a:extLst xmlns:a="http://schemas.openxmlformats.org/drawingml/2006/main">
               <a:ext uri="{FF2B5EF4-FFF2-40B4-BE49-F238E27FC236}">
-                <a16:creationId xmlns:a16="http://schemas.microsoft.com/office/drawing/2014/main" id="{C2B2546C-1C22-4827-B111-850CA8293724}"/>
+                <a16:creationId xmlns:a16="http://schemas.microsoft.com/office/drawing/2014/main" id="{45777481-F50E-419F-A2B5-91786FAB0F3B}"/>
               </a:ext>
             </a:extLst>
           </p:cNvPr>
@@ -10562,7 +10562,7 @@
     </p:spTree>
     <p:extLst>
       <p:ext uri="{BB962C8B-B14F-4D97-AF65-F5344CB8AC3E}">
-        <p14:creationId xmlns:p14="http://schemas.microsoft.com/office/powerpoint/2010/main" val="224496827"/>
+        <p14:creationId xmlns:p14="http://schemas.microsoft.com/office/powerpoint/2010/main" val="1311738306"/>
       </p:ext>
     </p:extLst>
   </p:cSld>
@@ -10593,7 +10593,7 @@
           <p:cNvPr id="54" name="">
             <a:extLst xmlns:a="http://schemas.openxmlformats.org/drawingml/2006/main">
               <a:ext uri="{FF2B5EF4-FFF2-40B4-BE49-F238E27FC236}">
-                <a16:creationId xmlns:a16="http://schemas.microsoft.com/office/drawing/2014/main" id="{8A3F166F-EB8A-4549-9031-2AE4BA132A73}"/>
+                <a16:creationId xmlns:a16="http://schemas.microsoft.com/office/drawing/2014/main" id="{E25069B6-0CE7-4427-8F96-E654B9C0ADF5}"/>
               </a:ext>
             </a:extLst>
           </p:cNvPr>
@@ -10650,7 +10650,7 @@
           <p:cNvPr id="2" name="">
             <a:extLst xmlns:a="http://schemas.openxmlformats.org/drawingml/2006/main">
               <a:ext uri="{FF2B5EF4-FFF2-40B4-BE49-F238E27FC236}">
-                <a16:creationId xmlns:a16="http://schemas.microsoft.com/office/drawing/2014/main" id="{FC993E3D-24AB-48E1-B109-1399EF1671D5}"/>
+                <a16:creationId xmlns:a16="http://schemas.microsoft.com/office/drawing/2014/main" id="{7905B4B3-A97A-4757-9B93-4BDBB0B6F028}"/>
               </a:ext>
             </a:extLst>
           </p:cNvPr>
@@ -10711,7 +10711,7 @@
           <p:nvPr/>
         </p:nvPicPr>
         <p:blipFill>
-          <a:blip xmlns:r="http://schemas.openxmlformats.org/officeDocument/2006/relationships" xmlns:a="http://schemas.openxmlformats.org/drawingml/2006/main" r:embed="R099f2b3081904ceb"/>
+          <a:blip xmlns:r="http://schemas.openxmlformats.org/officeDocument/2006/relationships" xmlns:a="http://schemas.openxmlformats.org/drawingml/2006/main" r:embed="Rbe44e6b0131e4027"/>
           <a:stretch xmlns:a="http://schemas.openxmlformats.org/drawingml/2006/main"/>
         </p:blipFill>
         <p:spPr>
@@ -10729,7 +10729,7 @@
           <p:cNvPr id="4" name="">
             <a:extLst xmlns:a="http://schemas.openxmlformats.org/drawingml/2006/main">
               <a:ext uri="{FF2B5EF4-FFF2-40B4-BE49-F238E27FC236}">
-                <a16:creationId xmlns:a16="http://schemas.microsoft.com/office/drawing/2014/main" id="{687F27C7-349A-4F3C-8A7E-9DE0D041F8B7}"/>
+                <a16:creationId xmlns:a16="http://schemas.microsoft.com/office/drawing/2014/main" id="{4BDCC446-713C-4C78-AFE8-CD7FD9768248}"/>
               </a:ext>
             </a:extLst>
           </p:cNvPr>
@@ -10764,7 +10764,7 @@
           <p:cNvPr id="5" name="">
             <a:extLst xmlns:a="http://schemas.openxmlformats.org/drawingml/2006/main">
               <a:ext uri="{FF2B5EF4-FFF2-40B4-BE49-F238E27FC236}">
-                <a16:creationId xmlns:a16="http://schemas.microsoft.com/office/drawing/2014/main" id="{FD348355-6801-4E13-AD9E-7E53F32314E0}"/>
+                <a16:creationId xmlns:a16="http://schemas.microsoft.com/office/drawing/2014/main" id="{52170586-BA74-4105-B153-34030D9D3D41}"/>
               </a:ext>
             </a:extLst>
           </p:cNvPr>
@@ -10821,7 +10821,7 @@
           <p:cNvPr id="6" name="">
             <a:extLst xmlns:a="http://schemas.openxmlformats.org/drawingml/2006/main">
               <a:ext uri="{FF2B5EF4-FFF2-40B4-BE49-F238E27FC236}">
-                <a16:creationId xmlns:a16="http://schemas.microsoft.com/office/drawing/2014/main" id="{A0CBB20F-E5EB-4A0A-80A4-36F470804077}"/>
+                <a16:creationId xmlns:a16="http://schemas.microsoft.com/office/drawing/2014/main" id="{C9E1A0B8-37C3-414C-9C30-9FA9DD06CC56}"/>
               </a:ext>
             </a:extLst>
           </p:cNvPr>
@@ -10856,7 +10856,7 @@
           <p:cNvPr id="7" name="">
             <a:extLst xmlns:a="http://schemas.openxmlformats.org/drawingml/2006/main">
               <a:ext uri="{FF2B5EF4-FFF2-40B4-BE49-F238E27FC236}">
-                <a16:creationId xmlns:a16="http://schemas.microsoft.com/office/drawing/2014/main" id="{3A94E4CD-EADB-41B8-83F3-D57A7D192F08}"/>
+                <a16:creationId xmlns:a16="http://schemas.microsoft.com/office/drawing/2014/main" id="{AB23691E-638D-40C1-AA61-1B62DDA9A108}"/>
               </a:ext>
             </a:extLst>
           </p:cNvPr>
@@ -10913,7 +10913,7 @@
           <p:cNvPr id="8" name="">
             <a:extLst xmlns:a="http://schemas.openxmlformats.org/drawingml/2006/main">
               <a:ext uri="{FF2B5EF4-FFF2-40B4-BE49-F238E27FC236}">
-                <a16:creationId xmlns:a16="http://schemas.microsoft.com/office/drawing/2014/main" id="{F240C902-2285-4E9E-A1DC-ED6C02951C3C}"/>
+                <a16:creationId xmlns:a16="http://schemas.microsoft.com/office/drawing/2014/main" id="{763BD2DE-ED06-4074-AE71-3E2F226E07D7}"/>
               </a:ext>
             </a:extLst>
           </p:cNvPr>
@@ -10948,7 +10948,7 @@
           <p:cNvPr id="9" name="">
             <a:extLst xmlns:a="http://schemas.openxmlformats.org/drawingml/2006/main">
               <a:ext uri="{FF2B5EF4-FFF2-40B4-BE49-F238E27FC236}">
-                <a16:creationId xmlns:a16="http://schemas.microsoft.com/office/drawing/2014/main" id="{F2FBD5D5-BD99-45F0-B934-BC766D8D1823}"/>
+                <a16:creationId xmlns:a16="http://schemas.microsoft.com/office/drawing/2014/main" id="{61585617-05EF-43AC-A6AC-2DEE0A31CE80}"/>
               </a:ext>
             </a:extLst>
           </p:cNvPr>
@@ -11005,7 +11005,7 @@
           <p:cNvPr id="10" name="">
             <a:extLst xmlns:a="http://schemas.openxmlformats.org/drawingml/2006/main">
               <a:ext uri="{FF2B5EF4-FFF2-40B4-BE49-F238E27FC236}">
-                <a16:creationId xmlns:a16="http://schemas.microsoft.com/office/drawing/2014/main" id="{2B8A37EB-2B3F-42B6-8736-E72DABD28102}"/>
+                <a16:creationId xmlns:a16="http://schemas.microsoft.com/office/drawing/2014/main" id="{14BDFA7D-11BE-4ECB-9215-98C3E20589E6}"/>
               </a:ext>
             </a:extLst>
           </p:cNvPr>
@@ -11040,7 +11040,7 @@
           <p:cNvPr id="11" name="">
             <a:extLst xmlns:a="http://schemas.openxmlformats.org/drawingml/2006/main">
               <a:ext uri="{FF2B5EF4-FFF2-40B4-BE49-F238E27FC236}">
-                <a16:creationId xmlns:a16="http://schemas.microsoft.com/office/drawing/2014/main" id="{FE0FEAAE-CFC8-4A17-B895-3B7C3D430BCB}"/>
+                <a16:creationId xmlns:a16="http://schemas.microsoft.com/office/drawing/2014/main" id="{68A9C025-C342-4D28-AF32-037731EB7C81}"/>
               </a:ext>
             </a:extLst>
           </p:cNvPr>
@@ -11097,7 +11097,7 @@
           <p:cNvPr id="12" name="">
             <a:extLst xmlns:a="http://schemas.openxmlformats.org/drawingml/2006/main">
               <a:ext uri="{FF2B5EF4-FFF2-40B4-BE49-F238E27FC236}">
-                <a16:creationId xmlns:a16="http://schemas.microsoft.com/office/drawing/2014/main" id="{EFA434E5-2518-4C85-9427-6EA1CE6C2332}"/>
+                <a16:creationId xmlns:a16="http://schemas.microsoft.com/office/drawing/2014/main" id="{F93B1F6F-08F0-49F5-BE18-0DF1E7FD1386}"/>
               </a:ext>
             </a:extLst>
           </p:cNvPr>
@@ -11132,7 +11132,7 @@
           <p:cNvPr id="13" name="">
             <a:extLst xmlns:a="http://schemas.openxmlformats.org/drawingml/2006/main">
               <a:ext uri="{FF2B5EF4-FFF2-40B4-BE49-F238E27FC236}">
-                <a16:creationId xmlns:a16="http://schemas.microsoft.com/office/drawing/2014/main" id="{2F4ECEF4-CECD-4C8C-AA2C-C36DF1C21FEB}"/>
+                <a16:creationId xmlns:a16="http://schemas.microsoft.com/office/drawing/2014/main" id="{CDA889F7-9C40-4748-890D-47D8C68FBAFB}"/>
               </a:ext>
             </a:extLst>
           </p:cNvPr>
@@ -11189,7 +11189,7 @@
           <p:cNvPr id="14" name="">
             <a:extLst xmlns:a="http://schemas.openxmlformats.org/drawingml/2006/main">
               <a:ext uri="{FF2B5EF4-FFF2-40B4-BE49-F238E27FC236}">
-                <a16:creationId xmlns:a16="http://schemas.microsoft.com/office/drawing/2014/main" id="{F3545833-527E-4ABE-9428-716CC5571B33}"/>
+                <a16:creationId xmlns:a16="http://schemas.microsoft.com/office/drawing/2014/main" id="{63C1E9CC-A46F-48C7-8A6B-43AC9478FA29}"/>
               </a:ext>
             </a:extLst>
           </p:cNvPr>
@@ -11224,7 +11224,7 @@
           <p:cNvPr id="15" name="">
             <a:extLst xmlns:a="http://schemas.openxmlformats.org/drawingml/2006/main">
               <a:ext uri="{FF2B5EF4-FFF2-40B4-BE49-F238E27FC236}">
-                <a16:creationId xmlns:a16="http://schemas.microsoft.com/office/drawing/2014/main" id="{BDF5D4FD-616C-4A7C-B09E-066D3E12FB3E}"/>
+                <a16:creationId xmlns:a16="http://schemas.microsoft.com/office/drawing/2014/main" id="{0F3C5F11-28E9-4BDD-A525-B152DAF5FB53}"/>
               </a:ext>
             </a:extLst>
           </p:cNvPr>
@@ -11281,7 +11281,7 @@
           <p:cNvPr id="16" name="">
             <a:extLst xmlns:a="http://schemas.openxmlformats.org/drawingml/2006/main">
               <a:ext uri="{FF2B5EF4-FFF2-40B4-BE49-F238E27FC236}">
-                <a16:creationId xmlns:a16="http://schemas.microsoft.com/office/drawing/2014/main" id="{DDD10F6C-17D8-4922-A3E8-23D21A87ED71}"/>
+                <a16:creationId xmlns:a16="http://schemas.microsoft.com/office/drawing/2014/main" id="{675FA452-BB81-4239-9E43-DE85829F810D}"/>
               </a:ext>
             </a:extLst>
           </p:cNvPr>
@@ -11316,7 +11316,7 @@
           <p:cNvPr id="17" name="">
             <a:extLst xmlns:a="http://schemas.openxmlformats.org/drawingml/2006/main">
               <a:ext uri="{FF2B5EF4-FFF2-40B4-BE49-F238E27FC236}">
-                <a16:creationId xmlns:a16="http://schemas.microsoft.com/office/drawing/2014/main" id="{24A13F24-5265-4F02-BB46-9CB3EDFD2199}"/>
+                <a16:creationId xmlns:a16="http://schemas.microsoft.com/office/drawing/2014/main" id="{FC9520B8-B27D-42F7-B87F-9D7EFE635451}"/>
               </a:ext>
             </a:extLst>
           </p:cNvPr>
@@ -11373,7 +11373,7 @@
           <p:cNvPr id="18" name="">
             <a:extLst xmlns:a="http://schemas.openxmlformats.org/drawingml/2006/main">
               <a:ext uri="{FF2B5EF4-FFF2-40B4-BE49-F238E27FC236}">
-                <a16:creationId xmlns:a16="http://schemas.microsoft.com/office/drawing/2014/main" id="{2D4EB140-0A55-4D3C-81E5-D6563F75A321}"/>
+                <a16:creationId xmlns:a16="http://schemas.microsoft.com/office/drawing/2014/main" id="{8DF66D50-A7C5-4B25-BF86-D4252243DC5E}"/>
               </a:ext>
             </a:extLst>
           </p:cNvPr>
@@ -11408,7 +11408,7 @@
           <p:cNvPr id="19" name="">
             <a:extLst xmlns:a="http://schemas.openxmlformats.org/drawingml/2006/main">
               <a:ext uri="{FF2B5EF4-FFF2-40B4-BE49-F238E27FC236}">
-                <a16:creationId xmlns:a16="http://schemas.microsoft.com/office/drawing/2014/main" id="{01CBC034-F782-453C-A075-E013ED49BE6E}"/>
+                <a16:creationId xmlns:a16="http://schemas.microsoft.com/office/drawing/2014/main" id="{5C0D3BC2-1793-4499-BBF6-B07E37CDF15C}"/>
               </a:ext>
             </a:extLst>
           </p:cNvPr>
@@ -11465,7 +11465,7 @@
           <p:cNvPr id="20" name="">
             <a:extLst xmlns:a="http://schemas.openxmlformats.org/drawingml/2006/main">
               <a:ext uri="{FF2B5EF4-FFF2-40B4-BE49-F238E27FC236}">
-                <a16:creationId xmlns:a16="http://schemas.microsoft.com/office/drawing/2014/main" id="{6E0206D0-95C5-4649-9EB6-81DD5B5AC669}"/>
+                <a16:creationId xmlns:a16="http://schemas.microsoft.com/office/drawing/2014/main" id="{C749DFC0-D9E4-4943-A345-18AB1D250EDA}"/>
               </a:ext>
             </a:extLst>
           </p:cNvPr>
@@ -11500,7 +11500,7 @@
           <p:cNvPr id="21" name="">
             <a:extLst xmlns:a="http://schemas.openxmlformats.org/drawingml/2006/main">
               <a:ext uri="{FF2B5EF4-FFF2-40B4-BE49-F238E27FC236}">
-                <a16:creationId xmlns:a16="http://schemas.microsoft.com/office/drawing/2014/main" id="{667E814E-E281-4393-8D7C-E2985194793F}"/>
+                <a16:creationId xmlns:a16="http://schemas.microsoft.com/office/drawing/2014/main" id="{A38549AE-A074-4D46-B7CD-9BD98F7F05BD}"/>
               </a:ext>
             </a:extLst>
           </p:cNvPr>
@@ -11557,7 +11557,7 @@
           <p:cNvPr id="22" name="">
             <a:extLst xmlns:a="http://schemas.openxmlformats.org/drawingml/2006/main">
               <a:ext uri="{FF2B5EF4-FFF2-40B4-BE49-F238E27FC236}">
-                <a16:creationId xmlns:a16="http://schemas.microsoft.com/office/drawing/2014/main" id="{863A495D-6736-4B88-AFA3-B5F329D60674}"/>
+                <a16:creationId xmlns:a16="http://schemas.microsoft.com/office/drawing/2014/main" id="{E222F959-3796-4A22-8500-C4EAD1B677C1}"/>
               </a:ext>
             </a:extLst>
           </p:cNvPr>
@@ -11592,7 +11592,7 @@
           <p:cNvPr id="23" name="">
             <a:extLst xmlns:a="http://schemas.openxmlformats.org/drawingml/2006/main">
               <a:ext uri="{FF2B5EF4-FFF2-40B4-BE49-F238E27FC236}">
-                <a16:creationId xmlns:a16="http://schemas.microsoft.com/office/drawing/2014/main" id="{8178ACF0-E8F7-4601-A326-233C4259FA0B}"/>
+                <a16:creationId xmlns:a16="http://schemas.microsoft.com/office/drawing/2014/main" id="{AD3BCD94-7C6B-4A04-9ABF-1D5D6C6DFC1E}"/>
               </a:ext>
             </a:extLst>
           </p:cNvPr>
@@ -11649,7 +11649,7 @@
           <p:cNvPr id="24" name="">
             <a:extLst xmlns:a="http://schemas.openxmlformats.org/drawingml/2006/main">
               <a:ext uri="{FF2B5EF4-FFF2-40B4-BE49-F238E27FC236}">
-                <a16:creationId xmlns:a16="http://schemas.microsoft.com/office/drawing/2014/main" id="{C35271FA-CC97-4851-AF31-23502776AD30}"/>
+                <a16:creationId xmlns:a16="http://schemas.microsoft.com/office/drawing/2014/main" id="{B4C65426-05F6-4963-8C85-39476351F101}"/>
               </a:ext>
             </a:extLst>
           </p:cNvPr>
@@ -11684,7 +11684,7 @@
           <p:cNvPr id="25" name="">
             <a:extLst xmlns:a="http://schemas.openxmlformats.org/drawingml/2006/main">
               <a:ext uri="{FF2B5EF4-FFF2-40B4-BE49-F238E27FC236}">
-                <a16:creationId xmlns:a16="http://schemas.microsoft.com/office/drawing/2014/main" id="{02FB563F-5941-40D8-9146-15ED7FBA56BB}"/>
+                <a16:creationId xmlns:a16="http://schemas.microsoft.com/office/drawing/2014/main" id="{23C33EF5-A96D-4CA3-9074-F0EF8E819C2F}"/>
               </a:ext>
             </a:extLst>
           </p:cNvPr>
@@ -11741,7 +11741,7 @@
           <p:cNvPr id="26" name="">
             <a:extLst xmlns:a="http://schemas.openxmlformats.org/drawingml/2006/main">
               <a:ext uri="{FF2B5EF4-FFF2-40B4-BE49-F238E27FC236}">
-                <a16:creationId xmlns:a16="http://schemas.microsoft.com/office/drawing/2014/main" id="{5B51EE15-B637-448B-A577-59F8FA8FF9B4}"/>
+                <a16:creationId xmlns:a16="http://schemas.microsoft.com/office/drawing/2014/main" id="{C2B7FE5C-1CAF-4E3A-9119-839B43F94DB6}"/>
               </a:ext>
             </a:extLst>
           </p:cNvPr>
@@ -11776,7 +11776,7 @@
           <p:cNvPr id="27" name="">
             <a:extLst xmlns:a="http://schemas.openxmlformats.org/drawingml/2006/main">
               <a:ext uri="{FF2B5EF4-FFF2-40B4-BE49-F238E27FC236}">
-                <a16:creationId xmlns:a16="http://schemas.microsoft.com/office/drawing/2014/main" id="{16C3B198-61A7-48A9-8C0B-F6D242FCA691}"/>
+                <a16:creationId xmlns:a16="http://schemas.microsoft.com/office/drawing/2014/main" id="{68384972-D681-4B5E-8E19-70EAB49EFF2C}"/>
               </a:ext>
             </a:extLst>
           </p:cNvPr>
@@ -11833,7 +11833,7 @@
           <p:cNvPr id="28" name="">
             <a:extLst xmlns:a="http://schemas.openxmlformats.org/drawingml/2006/main">
               <a:ext uri="{FF2B5EF4-FFF2-40B4-BE49-F238E27FC236}">
-                <a16:creationId xmlns:a16="http://schemas.microsoft.com/office/drawing/2014/main" id="{1485E92B-4FC1-4C48-BAFB-7ED6331B4DB1}"/>
+                <a16:creationId xmlns:a16="http://schemas.microsoft.com/office/drawing/2014/main" id="{706024A5-145F-4C9F-B2D2-AAD44EF807E1}"/>
               </a:ext>
             </a:extLst>
           </p:cNvPr>
@@ -11868,7 +11868,7 @@
           <p:cNvPr id="29" name="">
             <a:extLst xmlns:a="http://schemas.openxmlformats.org/drawingml/2006/main">
               <a:ext uri="{FF2B5EF4-FFF2-40B4-BE49-F238E27FC236}">
-                <a16:creationId xmlns:a16="http://schemas.microsoft.com/office/drawing/2014/main" id="{81F4A33E-E559-479A-B180-2B303C80591F}"/>
+                <a16:creationId xmlns:a16="http://schemas.microsoft.com/office/drawing/2014/main" id="{D1545039-6B13-407D-989B-4FC2885DC98B}"/>
               </a:ext>
             </a:extLst>
           </p:cNvPr>
@@ -11925,7 +11925,7 @@
           <p:cNvPr id="30" name="">
             <a:extLst xmlns:a="http://schemas.openxmlformats.org/drawingml/2006/main">
               <a:ext uri="{FF2B5EF4-FFF2-40B4-BE49-F238E27FC236}">
-                <a16:creationId xmlns:a16="http://schemas.microsoft.com/office/drawing/2014/main" id="{26781B21-CCFC-4B21-A3EF-873402C5B037}"/>
+                <a16:creationId xmlns:a16="http://schemas.microsoft.com/office/drawing/2014/main" id="{9A62CCF3-E33B-4E23-A170-D73F3CC9237F}"/>
               </a:ext>
             </a:extLst>
           </p:cNvPr>
@@ -11960,7 +11960,7 @@
           <p:cNvPr id="31" name="">
             <a:extLst xmlns:a="http://schemas.openxmlformats.org/drawingml/2006/main">
               <a:ext uri="{FF2B5EF4-FFF2-40B4-BE49-F238E27FC236}">
-                <a16:creationId xmlns:a16="http://schemas.microsoft.com/office/drawing/2014/main" id="{4A937866-AE59-4A7D-BDC3-C386A1ED3F25}"/>
+                <a16:creationId xmlns:a16="http://schemas.microsoft.com/office/drawing/2014/main" id="{25D5CF43-EE3E-4D29-B27D-52A6FA284377}"/>
               </a:ext>
             </a:extLst>
           </p:cNvPr>
@@ -12017,7 +12017,7 @@
           <p:cNvPr id="32" name="">
             <a:extLst xmlns:a="http://schemas.openxmlformats.org/drawingml/2006/main">
               <a:ext uri="{FF2B5EF4-FFF2-40B4-BE49-F238E27FC236}">
-                <a16:creationId xmlns:a16="http://schemas.microsoft.com/office/drawing/2014/main" id="{F1B34102-FE6B-4FFB-AB6E-EB0C76322C1B}"/>
+                <a16:creationId xmlns:a16="http://schemas.microsoft.com/office/drawing/2014/main" id="{7D1A0340-5FC4-4E9B-B1DE-10F8735875C5}"/>
               </a:ext>
             </a:extLst>
           </p:cNvPr>
@@ -12052,7 +12052,7 @@
           <p:cNvPr id="33" name="">
             <a:extLst xmlns:a="http://schemas.openxmlformats.org/drawingml/2006/main">
               <a:ext uri="{FF2B5EF4-FFF2-40B4-BE49-F238E27FC236}">
-                <a16:creationId xmlns:a16="http://schemas.microsoft.com/office/drawing/2014/main" id="{F4BAB94E-CDBC-4E09-82B9-9A447CFCE81A}"/>
+                <a16:creationId xmlns:a16="http://schemas.microsoft.com/office/drawing/2014/main" id="{D55C32BA-607E-4BA4-8B96-178ED67AB8AC}"/>
               </a:ext>
             </a:extLst>
           </p:cNvPr>
@@ -12109,7 +12109,7 @@
           <p:cNvPr id="34" name="">
             <a:extLst xmlns:a="http://schemas.openxmlformats.org/drawingml/2006/main">
               <a:ext uri="{FF2B5EF4-FFF2-40B4-BE49-F238E27FC236}">
-                <a16:creationId xmlns:a16="http://schemas.microsoft.com/office/drawing/2014/main" id="{419734C8-5E30-4C40-BDCF-4B49FD889FE7}"/>
+                <a16:creationId xmlns:a16="http://schemas.microsoft.com/office/drawing/2014/main" id="{795D40A8-F821-4086-A56E-CF9E0014E203}"/>
               </a:ext>
             </a:extLst>
           </p:cNvPr>
@@ -12144,7 +12144,7 @@
           <p:cNvPr id="35" name="">
             <a:extLst xmlns:a="http://schemas.openxmlformats.org/drawingml/2006/main">
               <a:ext uri="{FF2B5EF4-FFF2-40B4-BE49-F238E27FC236}">
-                <a16:creationId xmlns:a16="http://schemas.microsoft.com/office/drawing/2014/main" id="{3113CD39-C3D4-4A91-9827-20156AD3B41B}"/>
+                <a16:creationId xmlns:a16="http://schemas.microsoft.com/office/drawing/2014/main" id="{2E392A42-264D-4C3E-A4B9-DF71166DAD57}"/>
               </a:ext>
             </a:extLst>
           </p:cNvPr>
@@ -12201,7 +12201,7 @@
           <p:cNvPr id="36" name="">
             <a:extLst xmlns:a="http://schemas.openxmlformats.org/drawingml/2006/main">
               <a:ext uri="{FF2B5EF4-FFF2-40B4-BE49-F238E27FC236}">
-                <a16:creationId xmlns:a16="http://schemas.microsoft.com/office/drawing/2014/main" id="{A87CE91C-6018-400B-91DB-677EBD7CBC1B}"/>
+                <a16:creationId xmlns:a16="http://schemas.microsoft.com/office/drawing/2014/main" id="{F526079B-49F1-447A-A632-40CDC2BE49E4}"/>
               </a:ext>
             </a:extLst>
           </p:cNvPr>
@@ -12236,7 +12236,7 @@
           <p:cNvPr id="37" name="">
             <a:extLst xmlns:a="http://schemas.openxmlformats.org/drawingml/2006/main">
               <a:ext uri="{FF2B5EF4-FFF2-40B4-BE49-F238E27FC236}">
-                <a16:creationId xmlns:a16="http://schemas.microsoft.com/office/drawing/2014/main" id="{83F3BD88-D8E0-4A22-8C3D-115F91F5BD8B}"/>
+                <a16:creationId xmlns:a16="http://schemas.microsoft.com/office/drawing/2014/main" id="{A694A158-9CE5-4370-8478-C50CA1D6AF4C}"/>
               </a:ext>
             </a:extLst>
           </p:cNvPr>
@@ -12293,7 +12293,7 @@
           <p:cNvPr id="38" name="">
             <a:extLst xmlns:a="http://schemas.openxmlformats.org/drawingml/2006/main">
               <a:ext uri="{FF2B5EF4-FFF2-40B4-BE49-F238E27FC236}">
-                <a16:creationId xmlns:a16="http://schemas.microsoft.com/office/drawing/2014/main" id="{549E99FD-204B-42B7-A993-B13368DB7B87}"/>
+                <a16:creationId xmlns:a16="http://schemas.microsoft.com/office/drawing/2014/main" id="{56DFEACC-F741-423D-A901-58365806E007}"/>
               </a:ext>
             </a:extLst>
           </p:cNvPr>
@@ -12328,7 +12328,7 @@
           <p:cNvPr id="39" name="">
             <a:extLst xmlns:a="http://schemas.openxmlformats.org/drawingml/2006/main">
               <a:ext uri="{FF2B5EF4-FFF2-40B4-BE49-F238E27FC236}">
-                <a16:creationId xmlns:a16="http://schemas.microsoft.com/office/drawing/2014/main" id="{37AC50BC-A116-405C-9E78-829673306811}"/>
+                <a16:creationId xmlns:a16="http://schemas.microsoft.com/office/drawing/2014/main" id="{4C585F97-243C-4EA0-B525-E8A67F9A0239}"/>
               </a:ext>
             </a:extLst>
           </p:cNvPr>
@@ -12385,7 +12385,7 @@
           <p:cNvPr id="40" name="">
             <a:extLst xmlns:a="http://schemas.openxmlformats.org/drawingml/2006/main">
               <a:ext uri="{FF2B5EF4-FFF2-40B4-BE49-F238E27FC236}">
-                <a16:creationId xmlns:a16="http://schemas.microsoft.com/office/drawing/2014/main" id="{61C0C2F3-394D-4849-B8EB-517FFB38DCCD}"/>
+                <a16:creationId xmlns:a16="http://schemas.microsoft.com/office/drawing/2014/main" id="{7F74CB3C-6CEB-41B5-B358-02AFC4CC0A50}"/>
               </a:ext>
             </a:extLst>
           </p:cNvPr>
@@ -12420,7 +12420,7 @@
           <p:cNvPr id="41" name="">
             <a:extLst xmlns:a="http://schemas.openxmlformats.org/drawingml/2006/main">
               <a:ext uri="{FF2B5EF4-FFF2-40B4-BE49-F238E27FC236}">
-                <a16:creationId xmlns:a16="http://schemas.microsoft.com/office/drawing/2014/main" id="{9807A70C-DE2F-4F6F-B3AF-4B6337775BA1}"/>
+                <a16:creationId xmlns:a16="http://schemas.microsoft.com/office/drawing/2014/main" id="{74799DAB-44DD-46A9-B158-93612FA88E95}"/>
               </a:ext>
             </a:extLst>
           </p:cNvPr>
@@ -12477,7 +12477,7 @@
           <p:cNvPr id="42" name="">
             <a:extLst xmlns:a="http://schemas.openxmlformats.org/drawingml/2006/main">
               <a:ext uri="{FF2B5EF4-FFF2-40B4-BE49-F238E27FC236}">
-                <a16:creationId xmlns:a16="http://schemas.microsoft.com/office/drawing/2014/main" id="{7EDD0C8C-0A15-4B4E-835D-E8E62A15DAEF}"/>
+                <a16:creationId xmlns:a16="http://schemas.microsoft.com/office/drawing/2014/main" id="{C4E15E8A-F41B-4613-8321-212C034EFF53}"/>
               </a:ext>
             </a:extLst>
           </p:cNvPr>
@@ -12512,7 +12512,7 @@
           <p:cNvPr id="43" name="">
             <a:extLst xmlns:a="http://schemas.openxmlformats.org/drawingml/2006/main">
               <a:ext uri="{FF2B5EF4-FFF2-40B4-BE49-F238E27FC236}">
-                <a16:creationId xmlns:a16="http://schemas.microsoft.com/office/drawing/2014/main" id="{289E5868-593A-4E4D-BC6A-0511ECEE890C}"/>
+                <a16:creationId xmlns:a16="http://schemas.microsoft.com/office/drawing/2014/main" id="{464628D3-5464-484B-8F51-64514F6E07B3}"/>
               </a:ext>
             </a:extLst>
           </p:cNvPr>
@@ -12569,7 +12569,7 @@
           <p:cNvPr id="44" name="">
             <a:extLst xmlns:a="http://schemas.openxmlformats.org/drawingml/2006/main">
               <a:ext uri="{FF2B5EF4-FFF2-40B4-BE49-F238E27FC236}">
-                <a16:creationId xmlns:a16="http://schemas.microsoft.com/office/drawing/2014/main" id="{3BA0D09C-FD59-4EC3-8AE1-EB605B001211}"/>
+                <a16:creationId xmlns:a16="http://schemas.microsoft.com/office/drawing/2014/main" id="{D59A0DBE-82D0-425F-9E7C-48351AB41F8A}"/>
               </a:ext>
             </a:extLst>
           </p:cNvPr>
@@ -12604,7 +12604,7 @@
           <p:cNvPr id="45" name="">
             <a:extLst xmlns:a="http://schemas.openxmlformats.org/drawingml/2006/main">
               <a:ext uri="{FF2B5EF4-FFF2-40B4-BE49-F238E27FC236}">
-                <a16:creationId xmlns:a16="http://schemas.microsoft.com/office/drawing/2014/main" id="{5857C9BC-CD0C-4D3E-8817-7F56303201BE}"/>
+                <a16:creationId xmlns:a16="http://schemas.microsoft.com/office/drawing/2014/main" id="{BA93A861-D687-49AE-B3E4-C56FDB4E8979}"/>
               </a:ext>
             </a:extLst>
           </p:cNvPr>
@@ -12661,7 +12661,7 @@
           <p:cNvPr id="46" name="">
             <a:extLst xmlns:a="http://schemas.openxmlformats.org/drawingml/2006/main">
               <a:ext uri="{FF2B5EF4-FFF2-40B4-BE49-F238E27FC236}">
-                <a16:creationId xmlns:a16="http://schemas.microsoft.com/office/drawing/2014/main" id="{02378F46-BAA1-482A-8453-EDCAC84024D4}"/>
+                <a16:creationId xmlns:a16="http://schemas.microsoft.com/office/drawing/2014/main" id="{8994B032-BB91-4E2E-8C34-8DB5A4F8FBFD}"/>
               </a:ext>
             </a:extLst>
           </p:cNvPr>
@@ -12696,7 +12696,7 @@
           <p:cNvPr id="47" name="">
             <a:extLst xmlns:a="http://schemas.openxmlformats.org/drawingml/2006/main">
               <a:ext uri="{FF2B5EF4-FFF2-40B4-BE49-F238E27FC236}">
-                <a16:creationId xmlns:a16="http://schemas.microsoft.com/office/drawing/2014/main" id="{5086A5CF-F173-47B3-A855-51BD1830B3B6}"/>
+                <a16:creationId xmlns:a16="http://schemas.microsoft.com/office/drawing/2014/main" id="{B41CA970-4B0A-49B2-9822-4F2CF48B7901}"/>
               </a:ext>
             </a:extLst>
           </p:cNvPr>
@@ -12753,7 +12753,7 @@
           <p:cNvPr id="48" name="">
             <a:extLst xmlns:a="http://schemas.openxmlformats.org/drawingml/2006/main">
               <a:ext uri="{FF2B5EF4-FFF2-40B4-BE49-F238E27FC236}">
-                <a16:creationId xmlns:a16="http://schemas.microsoft.com/office/drawing/2014/main" id="{C1D926A6-4B8C-4CC6-A22C-59213C92F68B}"/>
+                <a16:creationId xmlns:a16="http://schemas.microsoft.com/office/drawing/2014/main" id="{25DBAFF7-D459-47D8-A484-05B1058DF086}"/>
               </a:ext>
             </a:extLst>
           </p:cNvPr>
@@ -12788,7 +12788,7 @@
           <p:cNvPr id="49" name="">
             <a:extLst xmlns:a="http://schemas.openxmlformats.org/drawingml/2006/main">
               <a:ext uri="{FF2B5EF4-FFF2-40B4-BE49-F238E27FC236}">
-                <a16:creationId xmlns:a16="http://schemas.microsoft.com/office/drawing/2014/main" id="{AB9C994B-5FA8-4730-8AA5-075AE7E14128}"/>
+                <a16:creationId xmlns:a16="http://schemas.microsoft.com/office/drawing/2014/main" id="{2C30ECA6-98B5-42C2-8347-CF3D193CAFAE}"/>
               </a:ext>
             </a:extLst>
           </p:cNvPr>
@@ -12845,7 +12845,7 @@
           <p:cNvPr id="50" name="">
             <a:extLst xmlns:a="http://schemas.openxmlformats.org/drawingml/2006/main">
               <a:ext uri="{FF2B5EF4-FFF2-40B4-BE49-F238E27FC236}">
-                <a16:creationId xmlns:a16="http://schemas.microsoft.com/office/drawing/2014/main" id="{74E3F952-9290-4DFB-A0A8-79500C965C31}"/>
+                <a16:creationId xmlns:a16="http://schemas.microsoft.com/office/drawing/2014/main" id="{7F9050B5-E517-40E8-9F2B-FE27EA0D3333}"/>
               </a:ext>
             </a:extLst>
           </p:cNvPr>
@@ -12880,7 +12880,7 @@
           <p:cNvPr id="51" name="">
             <a:extLst xmlns:a="http://schemas.openxmlformats.org/drawingml/2006/main">
               <a:ext uri="{FF2B5EF4-FFF2-40B4-BE49-F238E27FC236}">
-                <a16:creationId xmlns:a16="http://schemas.microsoft.com/office/drawing/2014/main" id="{EAE6768D-4633-45C1-9D81-136FD29720CB}"/>
+                <a16:creationId xmlns:a16="http://schemas.microsoft.com/office/drawing/2014/main" id="{44306D8C-2C2D-4D66-85F2-3A2785F10A81}"/>
               </a:ext>
             </a:extLst>
           </p:cNvPr>
@@ -12937,7 +12937,7 @@
           <p:cNvPr id="52" name="">
             <a:extLst xmlns:a="http://schemas.openxmlformats.org/drawingml/2006/main">
               <a:ext uri="{FF2B5EF4-FFF2-40B4-BE49-F238E27FC236}">
-                <a16:creationId xmlns:a16="http://schemas.microsoft.com/office/drawing/2014/main" id="{92FC38C3-E773-430D-9140-0943BEE4F319}"/>
+                <a16:creationId xmlns:a16="http://schemas.microsoft.com/office/drawing/2014/main" id="{4CBC33AA-AECA-41A2-AD4F-292BBFE06BB1}"/>
               </a:ext>
             </a:extLst>
           </p:cNvPr>
@@ -12994,7 +12994,7 @@
           <p:cNvPr id="53" name="">
             <a:extLst xmlns:a="http://schemas.openxmlformats.org/drawingml/2006/main">
               <a:ext uri="{FF2B5EF4-FFF2-40B4-BE49-F238E27FC236}">
-                <a16:creationId xmlns:a16="http://schemas.microsoft.com/office/drawing/2014/main" id="{0575987E-6B85-4494-9AF0-D4601DDF9DFA}"/>
+                <a16:creationId xmlns:a16="http://schemas.microsoft.com/office/drawing/2014/main" id="{676384D3-2A4D-4C47-B94D-3A9CC4B5CDC0}"/>
               </a:ext>
             </a:extLst>
           </p:cNvPr>
@@ -13049,7 +13049,7 @@
     </p:spTree>
     <p:extLst>
       <p:ext uri="{BB962C8B-B14F-4D97-AF65-F5344CB8AC3E}">
-        <p14:creationId xmlns:p14="http://schemas.microsoft.com/office/powerpoint/2010/main" val="1900323581"/>
+        <p14:creationId xmlns:p14="http://schemas.microsoft.com/office/powerpoint/2010/main" val="1824443877"/>
       </p:ext>
     </p:extLst>
   </p:cSld>

</xml_diff>